<commit_message>
refine NVC pitch materials based on feedback
- Slide 1: reframe around choice, not the mountain story
- Market: $50B+ agentic AI by 2030 (sourced), OpenAI $200B context
- Pricing: free = offline + on-device transcription, $1-2 = sync, $5 = cloud transcription + AI
- Traction: reframe as "built from zero, solo, no funding" + what exists
- Fix pendant callout overlapping text on Daily slide
- Add community as growth engine to trust slide
- Update exec summary and markdown draft to match

Co-Authored-By: Claude Opus 4.6 <noreply@anthropic.com>
</commit_message>
<xml_diff>
--- a/nvc-pitch-deck.pptx
+++ b/nvc-pitch-deck.pptx
@@ -3174,7 +3174,7 @@
           <a:p>
             <a:pPr algn="l">
               <a:lnSpc>
-                <a:spcPct val="115000"/>
+                <a:spcPct val="112000"/>
               </a:lnSpc>
               <a:spcBef>
                 <a:spcPts val="0"/>
@@ -3182,7 +3182,7 @@
               <a:spcAft>
                 <a:spcPts val="0"/>
               </a:spcAft>
-              <a:defRPr sz="4400" b="0">
+              <a:defRPr sz="4800" b="0">
                 <a:solidFill>
                   <a:srgbClr val="2C2A26"/>
                 </a:solidFill>
@@ -3190,19 +3190,15 @@
               </a:defRPr>
             </a:pPr>
             <a:r>
-              <a:t>I want to hike up a mountain,</a:t>
+              <a:t>Technology should help us</a:t>
             </a:r>
             <a:br/>
             <a:r>
-              <a:t>share my ideas as I walk,</a:t>
+              <a:t>live fully — not demand</a:t>
             </a:r>
             <a:br/>
             <a:r>
-              <a:t>and come back down</a:t>
-            </a:r>
-            <a:br/>
-            <a:r>
-              <a:t>to a working app.</a:t>
+              <a:t>we stop living to use it.</a:t>
             </a:r>
           </a:p>
         </p:txBody>
@@ -3215,8 +3211,8 @@
         </p:nvSpPr>
         <p:spPr>
           <a:xfrm>
-            <a:off x="1097280" y="4754880"/>
-            <a:ext cx="7315200" cy="914400"/>
+            <a:off x="1097280" y="4572000"/>
+            <a:ext cx="7315200" cy="1097280"/>
           </a:xfrm>
           <a:prstGeom prst="rect">
             <a:avLst/>
@@ -3247,15 +3243,19 @@
               </a:defRPr>
             </a:pPr>
             <a:r>
-              <a:t>That dream is closer to real than it's ever been.</a:t>
+              <a:t>I want to hike up a mountain, share my ideas as I walk,</a:t>
             </a:r>
             <a:br/>
             <a:r>
+              <a:t>and come back down to a working app.</a:t>
+            </a:r>
+            <a:br/>
+            <a:r>
               <a:t>But I also want to hold my nephew. Be outside. Live a full life.</a:t>
             </a:r>
             <a:br/>
             <a:r>
-              <a:t>Parachute exists because we shouldn't have to choose.</a:t>
+              <a:t>We shouldn't have to choose.</a:t>
             </a:r>
           </a:p>
         </p:txBody>
@@ -4035,11 +4035,11 @@
               </a:defRPr>
             </a:pPr>
             <a:r>
-              <a:t>OpenClaw — 300K+ GitHub stars in 3 months. Claude Cowork — recurring agents, messaging via Telegram.</a:t>
+              <a:t>Hundreds of millions of people already pay $20-200/month for AI tools.</a:t>
             </a:r>
             <a:br/>
             <a:r>
-              <a:t>ZoComputer. Perplexity Computer. Manus. The race is on.</a:t>
+              <a:t>OpenClaw — 300K+ stars in 3 months. Claude Cowork. ZoComputer. Perplexity Computer. Manus.</a:t>
             </a:r>
           </a:p>
         </p:txBody>
@@ -4084,7 +4084,7 @@
               </a:defRPr>
             </a:pPr>
             <a:r>
-              <a:t>$16B</a:t>
+              <a:t>$50B+</a:t>
             </a:r>
           </a:p>
         </p:txBody>
@@ -4097,8 +4097,8 @@
         </p:nvSpPr>
         <p:spPr>
           <a:xfrm>
-            <a:off x="3840480" y="4983480"/>
-            <a:ext cx="2743200" cy="731520"/>
+            <a:off x="4114800" y="4983480"/>
+            <a:ext cx="4572000" cy="731520"/>
           </a:xfrm>
           <a:prstGeom prst="rect">
             <a:avLst/>
@@ -4129,11 +4129,11 @@
               </a:defRPr>
             </a:pPr>
             <a:r>
-              <a:t>market today</a:t>
+              <a:t>agentic AI market by 2030 · 44% CAGR</a:t>
             </a:r>
             <a:br/>
             <a:r>
-              <a:t>$268B by 2035 · 41% CAGR</a:t>
+              <a:t>OpenAI alone projects $200B revenue by 2030</a:t>
             </a:r>
           </a:p>
         </p:txBody>
@@ -4178,7 +4178,7 @@
               </a:defRPr>
             </a:pPr>
             <a:r>
-              <a:t>But they're all building for the 5% who are already bought in.</a:t>
+              <a:t>The question isn't whether this market exists — it's who they'll trust.</a:t>
             </a:r>
           </a:p>
         </p:txBody>
@@ -4534,7 +4534,7 @@
         <p:spPr>
           <a:xfrm>
             <a:off x="1097280" y="3200400"/>
-            <a:ext cx="5029200" cy="3200400"/>
+            <a:ext cx="5029200" cy="2560320"/>
           </a:xfrm>
           <a:prstGeom prst="rect">
             <a:avLst/>
@@ -4549,7 +4549,7 @@
           <a:p>
             <a:pPr algn="l">
               <a:lnSpc>
-                <a:spcPct val="155000"/>
+                <a:spcPct val="150000"/>
               </a:lnSpc>
               <a:spcBef>
                 <a:spcPts val="0"/>
@@ -4593,8 +4593,48 @@
             <a:r>
               <a:t>  ·  Weekly synthesis of your thinking</a:t>
             </a:r>
-            <a:br/>
-            <a:br/>
+          </a:p>
+        </p:txBody>
+      </p:sp>
+      <p:sp>
+        <p:nvSpPr>
+          <p:cNvPr id="5" name="TextBox 4"/>
+          <p:cNvSpPr txBox="1"/>
+          <p:nvPr/>
+        </p:nvSpPr>
+        <p:spPr>
+          <a:xfrm>
+            <a:off x="1097280" y="5943600"/>
+            <a:ext cx="5029200" cy="457200"/>
+          </a:xfrm>
+          <a:prstGeom prst="rect">
+            <a:avLst/>
+          </a:prstGeom>
+          <a:noFill/>
+        </p:spPr>
+        <p:txBody>
+          <a:bodyPr wrap="square">
+            <a:spAutoFit/>
+          </a:bodyPr>
+          <a:lstStyle/>
+          <a:p>
+            <a:pPr algn="l">
+              <a:lnSpc>
+                <a:spcPct val="120000"/>
+              </a:lnSpc>
+              <a:spcBef>
+                <a:spcPts val="0"/>
+              </a:spcBef>
+              <a:spcAft>
+                <a:spcPts val="0"/>
+              </a:spcAft>
+              <a:defRPr sz="1800" b="0">
+                <a:solidFill>
+                  <a:srgbClr val="2C2A26"/>
+                </a:solidFill>
+                <a:latin typeface="Calibri"/>
+              </a:defRPr>
+            </a:pPr>
             <a:r>
               <a:t>No learning curve. No technical sophistication required.</a:t>
             </a:r>
@@ -4603,14 +4643,14 @@
       </p:sp>
       <p:sp>
         <p:nvSpPr>
-          <p:cNvPr id="5" name="Rounded Rectangle 4"/>
+          <p:cNvPr id="6" name="Rounded Rectangle 5"/>
           <p:cNvSpPr/>
           <p:nvPr/>
         </p:nvSpPr>
         <p:spPr>
           <a:xfrm>
-            <a:off x="7132320" y="2743200"/>
-            <a:ext cx="4114800" cy="3474720"/>
+            <a:off x="7132320" y="3200400"/>
+            <a:ext cx="4114800" cy="2743200"/>
           </a:xfrm>
           <a:prstGeom prst="roundRect">
             <a:avLst/>
@@ -4648,13 +4688,13 @@
       </p:sp>
       <p:sp>
         <p:nvSpPr>
-          <p:cNvPr id="6" name="TextBox 5"/>
+          <p:cNvPr id="7" name="TextBox 6"/>
           <p:cNvSpPr txBox="1"/>
           <p:nvPr/>
         </p:nvSpPr>
         <p:spPr>
           <a:xfrm>
-            <a:off x="7498079" y="3108960"/>
+            <a:off x="7498079" y="3474720"/>
             <a:ext cx="3383280" cy="365760"/>
           </a:xfrm>
           <a:prstGeom prst="rect">
@@ -4693,14 +4733,14 @@
       </p:sp>
       <p:sp>
         <p:nvSpPr>
-          <p:cNvPr id="7" name="TextBox 6"/>
+          <p:cNvPr id="8" name="TextBox 7"/>
           <p:cNvSpPr txBox="1"/>
           <p:nvPr/>
         </p:nvSpPr>
         <p:spPr>
           <a:xfrm>
-            <a:off x="7498079" y="3566160"/>
-            <a:ext cx="3383280" cy="2286000"/>
+            <a:off x="7498079" y="3931920"/>
+            <a:ext cx="3383280" cy="1828800"/>
           </a:xfrm>
           <a:prstGeom prst="rect">
             <a:avLst/>
@@ -4715,7 +4755,7 @@
           <a:p>
             <a:pPr algn="l">
               <a:lnSpc>
-                <a:spcPct val="150000"/>
+                <a:spcPct val="145000"/>
               </a:lnSpc>
               <a:spcBef>
                 <a:spcPts val="0"/>
@@ -6144,7 +6184,7 @@
               </a:defRPr>
             </a:pPr>
             <a:r>
-              <a:t>Offline journal, local transcription, no sync</a:t>
+              <a:t>Offline journal + on-device transcription. Zero hosting cost.</a:t>
             </a:r>
           </a:p>
         </p:txBody>
@@ -6234,7 +6274,7 @@
               </a:defRPr>
             </a:pPr>
             <a:r>
-              <a:t>Cloud sync + transcription. AI starts here.</a:t>
+              <a:t>Cloud sync across devices. Your notes everywhere.</a:t>
             </a:r>
           </a:p>
         </p:txBody>
@@ -6367,7 +6407,7 @@
               </a:defRPr>
             </a:pPr>
             <a:r>
-              <a:t>Daily reflections, synthesis, pattern surfacing — the sweet spot</a:t>
+              <a:t>Cloud transcription + AI reflections, synthesis, pattern surfacing</a:t>
             </a:r>
           </a:p>
         </p:txBody>
@@ -6506,7 +6546,7 @@
             </a:r>
             <a:br/>
             <a:r>
-              <a:t>AI inference at $2-5 tiers uses cost-efficient models (Nvidia Nemotron). Margins are real.</a:t>
+              <a:t>AI at $5/mo uses cost-efficient models. Margins are real and improve as model costs drop.</a:t>
             </a:r>
           </a:p>
         </p:txBody>
@@ -6622,7 +6662,11 @@
               </a:defRPr>
             </a:pPr>
             <a:r>
-              <a:t>Small, capable, committed.</a:t>
+              <a:t>Built from zero.</a:t>
+            </a:r>
+            <a:br/>
+            <a:r>
+              <a:t>Solo. No funding.</a:t>
             </a:r>
           </a:p>
         </p:txBody>
@@ -6635,8 +6679,82 @@
         </p:nvSpPr>
         <p:spPr>
           <a:xfrm>
-            <a:off x="1097280" y="3017520"/>
-            <a:ext cx="2743200" cy="320040"/>
+            <a:off x="1097280" y="3200400"/>
+            <a:ext cx="5029200" cy="2743200"/>
+          </a:xfrm>
+          <a:prstGeom prst="rect">
+            <a:avLst/>
+          </a:prstGeom>
+          <a:noFill/>
+        </p:spPr>
+        <p:txBody>
+          <a:bodyPr wrap="square">
+            <a:spAutoFit/>
+          </a:bodyPr>
+          <a:lstStyle/>
+          <a:p>
+            <a:pPr algn="l">
+              <a:lnSpc>
+                <a:spcPct val="155000"/>
+              </a:lnSpc>
+              <a:spcBef>
+                <a:spcPts val="0"/>
+              </a:spcBef>
+              <a:spcAft>
+                <a:spcPts val="0"/>
+              </a:spcAft>
+              <a:defRPr sz="1600" b="0">
+                <a:solidFill>
+                  <a:srgbClr val="6B6860"/>
+                </a:solidFill>
+                <a:latin typeface="Calibri"/>
+              </a:defRPr>
+            </a:pPr>
+            <a:r>
+              <a:t>What exists today:</a:t>
+            </a:r>
+            <a:br/>
+            <a:br/>
+            <a:r>
+              <a:t>  ·  Working server, app, and graph-native memory</a:t>
+            </a:r>
+            <a:br/>
+            <a:r>
+              <a:t>  ·  Local voice transcription (fully offline)</a:t>
+            </a:r>
+            <a:br/>
+            <a:r>
+              <a:t>  ·  Multi-agent system with trust tiers</a:t>
+            </a:r>
+            <a:br/>
+            <a:r>
+              <a:t>  ·  Telegram, Discord, Matrix connectors</a:t>
+            </a:r>
+            <a:br/>
+            <a:r>
+              <a:t>  ·  Functional pendant prototype</a:t>
+            </a:r>
+            <a:br/>
+            <a:r>
+              <a:t>  ·  Beta launching next month</a:t>
+            </a:r>
+            <a:br/>
+            <a:r>
+              <a:t>  ·  PBC incorporated in Colorado</a:t>
+            </a:r>
+          </a:p>
+        </p:txBody>
+      </p:sp>
+      <p:sp>
+        <p:nvSpPr>
+          <p:cNvPr id="5" name="TextBox 4"/>
+          <p:cNvSpPr txBox="1"/>
+          <p:nvPr/>
+        </p:nvSpPr>
+        <p:spPr>
+          <a:xfrm>
+            <a:off x="7132320" y="3017520"/>
+            <a:ext cx="3657600" cy="320040"/>
           </a:xfrm>
           <a:prstGeom prst="rect">
             <a:avLst/>
@@ -6659,29 +6777,29 @@
               <a:spcAft>
                 <a:spcPts val="0"/>
               </a:spcAft>
-              <a:defRPr sz="1600" b="1">
-                <a:solidFill>
-                  <a:srgbClr val="2C2A26"/>
+              <a:defRPr sz="1100" b="1">
+                <a:solidFill>
+                  <a:srgbClr val="4A7C59"/>
                 </a:solidFill>
                 <a:latin typeface="Calibri"/>
               </a:defRPr>
             </a:pPr>
             <a:r>
-              <a:t>Aaron Gabriel Neyer</a:t>
-            </a:r>
-          </a:p>
-        </p:txBody>
-      </p:sp>
-      <p:sp>
-        <p:nvSpPr>
-          <p:cNvPr id="5" name="TextBox 4"/>
+              <a:t>THE TEAM</a:t>
+            </a:r>
+          </a:p>
+        </p:txBody>
+      </p:sp>
+      <p:sp>
+        <p:nvSpPr>
+          <p:cNvPr id="6" name="TextBox 5"/>
           <p:cNvSpPr txBox="1"/>
           <p:nvPr/>
         </p:nvSpPr>
         <p:spPr>
           <a:xfrm>
-            <a:off x="3840480" y="3017520"/>
-            <a:ext cx="4572000" cy="320040"/>
+            <a:off x="7132320" y="3566160"/>
+            <a:ext cx="4114800" cy="274320"/>
           </a:xfrm>
           <a:prstGeom prst="rect">
             <a:avLst/>
@@ -6704,29 +6822,29 @@
               <a:spcAft>
                 <a:spcPts val="0"/>
               </a:spcAft>
-              <a:defRPr sz="1400" b="0">
-                <a:solidFill>
-                  <a:srgbClr val="6B6860"/>
+              <a:defRPr sz="1400" b="1">
+                <a:solidFill>
+                  <a:srgbClr val="2C2A26"/>
                 </a:solidFill>
                 <a:latin typeface="Calibri"/>
               </a:defRPr>
             </a:pPr>
             <a:r>
-              <a:t>Founder · Product &amp; architecture · CU ATLAS</a:t>
-            </a:r>
-          </a:p>
-        </p:txBody>
-      </p:sp>
-      <p:sp>
-        <p:nvSpPr>
-          <p:cNvPr id="6" name="TextBox 5"/>
+              <a:t>Aaron Gabriel Neyer</a:t>
+            </a:r>
+          </a:p>
+        </p:txBody>
+      </p:sp>
+      <p:sp>
+        <p:nvSpPr>
+          <p:cNvPr id="7" name="TextBox 6"/>
           <p:cNvSpPr txBox="1"/>
           <p:nvPr/>
         </p:nvSpPr>
         <p:spPr>
           <a:xfrm>
-            <a:off x="1097280" y="3429000"/>
-            <a:ext cx="2743200" cy="320040"/>
+            <a:off x="7132320" y="3822192"/>
+            <a:ext cx="4114800" cy="274320"/>
           </a:xfrm>
           <a:prstGeom prst="rect">
             <a:avLst/>
@@ -6749,29 +6867,29 @@
               <a:spcAft>
                 <a:spcPts val="0"/>
               </a:spcAft>
-              <a:defRPr sz="1600" b="1">
-                <a:solidFill>
-                  <a:srgbClr val="2C2A26"/>
+              <a:defRPr sz="1200" b="0">
+                <a:solidFill>
+                  <a:srgbClr val="6B6860"/>
                 </a:solidFill>
                 <a:latin typeface="Calibri"/>
               </a:defRPr>
             </a:pPr>
             <a:r>
-              <a:t>Jon Bo</a:t>
-            </a:r>
-          </a:p>
-        </p:txBody>
-      </p:sp>
-      <p:sp>
-        <p:nvSpPr>
-          <p:cNvPr id="7" name="TextBox 6"/>
+              <a:t>Founder · Product &amp; architecture</a:t>
+            </a:r>
+          </a:p>
+        </p:txBody>
+      </p:sp>
+      <p:sp>
+        <p:nvSpPr>
+          <p:cNvPr id="8" name="TextBox 7"/>
           <p:cNvSpPr txBox="1"/>
           <p:nvPr/>
         </p:nvSpPr>
         <p:spPr>
           <a:xfrm>
-            <a:off x="3840480" y="3429000"/>
-            <a:ext cx="4572000" cy="320040"/>
+            <a:off x="7132320" y="4114800"/>
+            <a:ext cx="4114800" cy="274320"/>
           </a:xfrm>
           <a:prstGeom prst="rect">
             <a:avLst/>
@@ -6794,29 +6912,29 @@
               <a:spcAft>
                 <a:spcPts val="0"/>
               </a:spcAft>
-              <a:defRPr sz="1400" b="0">
-                <a:solidFill>
-                  <a:srgbClr val="6B6860"/>
+              <a:defRPr sz="1400" b="1">
+                <a:solidFill>
+                  <a:srgbClr val="2C2A26"/>
                 </a:solidFill>
                 <a:latin typeface="Calibri"/>
               </a:defRPr>
             </a:pPr>
             <a:r>
-              <a:t>Daily co-lead · Founding engineer, multiple startups</a:t>
-            </a:r>
-          </a:p>
-        </p:txBody>
-      </p:sp>
-      <p:sp>
-        <p:nvSpPr>
-          <p:cNvPr id="8" name="TextBox 7"/>
+              <a:t>Jon Bo</a:t>
+            </a:r>
+          </a:p>
+        </p:txBody>
+      </p:sp>
+      <p:sp>
+        <p:nvSpPr>
+          <p:cNvPr id="9" name="TextBox 8"/>
           <p:cNvSpPr txBox="1"/>
           <p:nvPr/>
         </p:nvSpPr>
         <p:spPr>
           <a:xfrm>
-            <a:off x="1097280" y="3840480"/>
-            <a:ext cx="2743200" cy="320040"/>
+            <a:off x="7132320" y="4370832"/>
+            <a:ext cx="4114800" cy="274320"/>
           </a:xfrm>
           <a:prstGeom prst="rect">
             <a:avLst/>
@@ -6839,29 +6957,29 @@
               <a:spcAft>
                 <a:spcPts val="0"/>
               </a:spcAft>
-              <a:defRPr sz="1600" b="1">
-                <a:solidFill>
-                  <a:srgbClr val="2C2A26"/>
+              <a:defRPr sz="1200" b="0">
+                <a:solidFill>
+                  <a:srgbClr val="6B6860"/>
                 </a:solidFill>
                 <a:latin typeface="Calibri"/>
               </a:defRPr>
             </a:pPr>
             <a:r>
-              <a:t>Lucian Hymer</a:t>
-            </a:r>
-          </a:p>
-        </p:txBody>
-      </p:sp>
-      <p:sp>
-        <p:nvSpPr>
-          <p:cNvPr id="9" name="TextBox 8"/>
+              <a:t>Daily co-lead · Founding engineer</a:t>
+            </a:r>
+          </a:p>
+        </p:txBody>
+      </p:sp>
+      <p:sp>
+        <p:nvSpPr>
+          <p:cNvPr id="10" name="TextBox 9"/>
           <p:cNvSpPr txBox="1"/>
           <p:nvPr/>
         </p:nvSpPr>
         <p:spPr>
           <a:xfrm>
-            <a:off x="3840480" y="3840480"/>
-            <a:ext cx="4572000" cy="320040"/>
+            <a:off x="7132320" y="4663440"/>
+            <a:ext cx="4114800" cy="274320"/>
           </a:xfrm>
           <a:prstGeom prst="rect">
             <a:avLst/>
@@ -6884,29 +7002,29 @@
               <a:spcAft>
                 <a:spcPts val="0"/>
               </a:spcAft>
-              <a:defRPr sz="1400" b="0">
-                <a:solidFill>
-                  <a:srgbClr val="6B6860"/>
+              <a:defRPr sz="1400" b="1">
+                <a:solidFill>
+                  <a:srgbClr val="2C2A26"/>
                 </a:solidFill>
                 <a:latin typeface="Calibri"/>
               </a:defRPr>
             </a:pPr>
             <a:r>
-              <a:t>Computer co-lead · Founding engineer, multiple startups</a:t>
-            </a:r>
-          </a:p>
-        </p:txBody>
-      </p:sp>
-      <p:sp>
-        <p:nvSpPr>
-          <p:cNvPr id="10" name="TextBox 9"/>
+              <a:t>Lucian Hymer</a:t>
+            </a:r>
+          </a:p>
+        </p:txBody>
+      </p:sp>
+      <p:sp>
+        <p:nvSpPr>
+          <p:cNvPr id="11" name="TextBox 10"/>
           <p:cNvSpPr txBox="1"/>
           <p:nvPr/>
         </p:nvSpPr>
         <p:spPr>
           <a:xfrm>
-            <a:off x="1097280" y="4251960"/>
-            <a:ext cx="2743200" cy="320040"/>
+            <a:off x="7132320" y="4919472"/>
+            <a:ext cx="4114800" cy="274320"/>
           </a:xfrm>
           <a:prstGeom prst="rect">
             <a:avLst/>
@@ -6929,29 +7047,29 @@
               <a:spcAft>
                 <a:spcPts val="0"/>
               </a:spcAft>
-              <a:defRPr sz="1600" b="1">
-                <a:solidFill>
-                  <a:srgbClr val="2C2A26"/>
+              <a:defRPr sz="1200" b="0">
+                <a:solidFill>
+                  <a:srgbClr val="6B6860"/>
                 </a:solidFill>
                 <a:latin typeface="Calibri"/>
               </a:defRPr>
             </a:pPr>
             <a:r>
-              <a:t>Marvin Melzer</a:t>
-            </a:r>
-          </a:p>
-        </p:txBody>
-      </p:sp>
-      <p:sp>
-        <p:nvSpPr>
-          <p:cNvPr id="11" name="TextBox 10"/>
+              <a:t>Computer co-lead · Founding engineer</a:t>
+            </a:r>
+          </a:p>
+        </p:txBody>
+      </p:sp>
+      <p:sp>
+        <p:nvSpPr>
+          <p:cNvPr id="12" name="TextBox 11"/>
           <p:cNvSpPr txBox="1"/>
           <p:nvPr/>
         </p:nvSpPr>
         <p:spPr>
           <a:xfrm>
-            <a:off x="3840480" y="4251960"/>
-            <a:ext cx="4572000" cy="320040"/>
+            <a:off x="7132320" y="5212080"/>
+            <a:ext cx="4114800" cy="274320"/>
           </a:xfrm>
           <a:prstGeom prst="rect">
             <a:avLst/>
@@ -6974,29 +7092,29 @@
               <a:spcAft>
                 <a:spcPts val="0"/>
               </a:spcAft>
-              <a:defRPr sz="1400" b="0">
-                <a:solidFill>
-                  <a:srgbClr val="6B6860"/>
+              <a:defRPr sz="1400" b="1">
+                <a:solidFill>
+                  <a:srgbClr val="2C2A26"/>
                 </a:solidFill>
                 <a:latin typeface="Calibri"/>
               </a:defRPr>
             </a:pPr>
             <a:r>
-              <a:t>Hardware · Pendant prototype · ATLAS</a:t>
-            </a:r>
-          </a:p>
-        </p:txBody>
-      </p:sp>
-      <p:sp>
-        <p:nvSpPr>
-          <p:cNvPr id="12" name="TextBox 11"/>
+              <a:t>Marvin Melzer</a:t>
+            </a:r>
+          </a:p>
+        </p:txBody>
+      </p:sp>
+      <p:sp>
+        <p:nvSpPr>
+          <p:cNvPr id="13" name="TextBox 12"/>
           <p:cNvSpPr txBox="1"/>
           <p:nvPr/>
         </p:nvSpPr>
         <p:spPr>
           <a:xfrm>
-            <a:off x="1097280" y="4663440"/>
-            <a:ext cx="2743200" cy="320040"/>
+            <a:off x="7132320" y="5468112"/>
+            <a:ext cx="4114800" cy="274320"/>
           </a:xfrm>
           <a:prstGeom prst="rect">
             <a:avLst/>
@@ -7019,29 +7137,29 @@
               <a:spcAft>
                 <a:spcPts val="0"/>
               </a:spcAft>
-              <a:defRPr sz="1600" b="1">
-                <a:solidFill>
-                  <a:srgbClr val="2C2A26"/>
+              <a:defRPr sz="1200" b="0">
+                <a:solidFill>
+                  <a:srgbClr val="6B6860"/>
                 </a:solidFill>
                 <a:latin typeface="Calibri"/>
               </a:defRPr>
             </a:pPr>
             <a:r>
-              <a:t>Neil Yarnal</a:t>
-            </a:r>
-          </a:p>
-        </p:txBody>
-      </p:sp>
-      <p:sp>
-        <p:nvSpPr>
-          <p:cNvPr id="13" name="TextBox 12"/>
+              <a:t>Hardware · Pendant prototype</a:t>
+            </a:r>
+          </a:p>
+        </p:txBody>
+      </p:sp>
+      <p:sp>
+        <p:nvSpPr>
+          <p:cNvPr id="14" name="TextBox 13"/>
           <p:cNvSpPr txBox="1"/>
           <p:nvPr/>
         </p:nvSpPr>
         <p:spPr>
           <a:xfrm>
-            <a:off x="3840480" y="4663440"/>
-            <a:ext cx="4572000" cy="320040"/>
+            <a:off x="7132320" y="5760720"/>
+            <a:ext cx="4114800" cy="274320"/>
           </a:xfrm>
           <a:prstGeom prst="rect">
             <a:avLst/>
@@ -7064,29 +7182,29 @@
               <a:spcAft>
                 <a:spcPts val="0"/>
               </a:spcAft>
-              <a:defRPr sz="1400" b="0">
-                <a:solidFill>
-                  <a:srgbClr val="6B6860"/>
+              <a:defRPr sz="1400" b="1">
+                <a:solidFill>
+                  <a:srgbClr val="2C2A26"/>
                 </a:solidFill>
                 <a:latin typeface="Calibri"/>
               </a:defRPr>
             </a:pPr>
             <a:r>
-              <a:t>Brand &amp; design</a:t>
-            </a:r>
-          </a:p>
-        </p:txBody>
-      </p:sp>
-      <p:sp>
-        <p:nvSpPr>
-          <p:cNvPr id="14" name="TextBox 13"/>
+              <a:t>Neil Yarnal</a:t>
+            </a:r>
+          </a:p>
+        </p:txBody>
+      </p:sp>
+      <p:sp>
+        <p:nvSpPr>
+          <p:cNvPr id="15" name="TextBox 14"/>
           <p:cNvSpPr txBox="1"/>
           <p:nvPr/>
         </p:nvSpPr>
         <p:spPr>
           <a:xfrm>
-            <a:off x="7772400" y="3017520"/>
-            <a:ext cx="1371600" cy="640080"/>
+            <a:off x="7132320" y="6016752"/>
+            <a:ext cx="4114800" cy="274320"/>
           </a:xfrm>
           <a:prstGeom prst="rect">
             <a:avLst/>
@@ -7099,7 +7217,7 @@
           </a:bodyPr>
           <a:lstStyle/>
           <a:p>
-            <a:pPr algn="ctr">
+            <a:pPr algn="l">
               <a:lnSpc>
                 <a:spcPct val="120000"/>
               </a:lnSpc>
@@ -7109,252 +7227,15 @@
               <a:spcAft>
                 <a:spcPts val="0"/>
               </a:spcAft>
-              <a:defRPr sz="3600" b="0">
-                <a:solidFill>
-                  <a:srgbClr val="4A7C59"/>
-                </a:solidFill>
-                <a:latin typeface="Georgia"/>
+              <a:defRPr sz="1200" b="0">
+                <a:solidFill>
+                  <a:srgbClr val="6B6860"/>
+                </a:solidFill>
+                <a:latin typeface="Calibri"/>
               </a:defRPr>
             </a:pPr>
             <a:r>
-              <a:t>200+</a:t>
-            </a:r>
-          </a:p>
-        </p:txBody>
-      </p:sp>
-      <p:sp>
-        <p:nvSpPr>
-          <p:cNvPr id="15" name="TextBox 14"/>
-          <p:cNvSpPr txBox="1"/>
-          <p:nvPr/>
-        </p:nvSpPr>
-        <p:spPr>
-          <a:xfrm>
-            <a:off x="7772400" y="3657600"/>
-            <a:ext cx="1371600" cy="640080"/>
-          </a:xfrm>
-          <a:prstGeom prst="rect">
-            <a:avLst/>
-          </a:prstGeom>
-          <a:noFill/>
-        </p:spPr>
-        <p:txBody>
-          <a:bodyPr wrap="square">
-            <a:spAutoFit/>
-          </a:bodyPr>
-          <a:lstStyle/>
-          <a:p>
-            <a:pPr algn="ctr">
-              <a:lnSpc>
-                <a:spcPct val="130000"/>
-              </a:lnSpc>
-              <a:spcBef>
-                <a:spcPts val="0"/>
-              </a:spcBef>
-              <a:spcAft>
-                <a:spcPts val="0"/>
-              </a:spcAft>
-              <a:defRPr sz="1100" b="0">
-                <a:solidFill>
-                  <a:srgbClr val="9A9690"/>
-                </a:solidFill>
-                <a:latin typeface="Calibri"/>
-              </a:defRPr>
-            </a:pPr>
-            <a:r>
-              <a:t>PRs merged</a:t>
-            </a:r>
-            <a:br/>
-            <a:r>
-              <a:t>since January</a:t>
-            </a:r>
-          </a:p>
-        </p:txBody>
-      </p:sp>
-      <p:sp>
-        <p:nvSpPr>
-          <p:cNvPr id="16" name="TextBox 15"/>
-          <p:cNvSpPr txBox="1"/>
-          <p:nvPr/>
-        </p:nvSpPr>
-        <p:spPr>
-          <a:xfrm>
-            <a:off x="9235440" y="3017520"/>
-            <a:ext cx="1371600" cy="640080"/>
-          </a:xfrm>
-          <a:prstGeom prst="rect">
-            <a:avLst/>
-          </a:prstGeom>
-          <a:noFill/>
-        </p:spPr>
-        <p:txBody>
-          <a:bodyPr wrap="square">
-            <a:spAutoFit/>
-          </a:bodyPr>
-          <a:lstStyle/>
-          <a:p>
-            <a:pPr algn="ctr">
-              <a:lnSpc>
-                <a:spcPct val="120000"/>
-              </a:lnSpc>
-              <a:spcBef>
-                <a:spcPts val="0"/>
-              </a:spcBef>
-              <a:spcAft>
-                <a:spcPts val="0"/>
-              </a:spcAft>
-              <a:defRPr sz="3600" b="0">
-                <a:solidFill>
-                  <a:srgbClr val="4A7C59"/>
-                </a:solidFill>
-                <a:latin typeface="Georgia"/>
-              </a:defRPr>
-            </a:pPr>
-            <a:r>
-              <a:t>300+</a:t>
-            </a:r>
-          </a:p>
-        </p:txBody>
-      </p:sp>
-      <p:sp>
-        <p:nvSpPr>
-          <p:cNvPr id="17" name="TextBox 16"/>
-          <p:cNvSpPr txBox="1"/>
-          <p:nvPr/>
-        </p:nvSpPr>
-        <p:spPr>
-          <a:xfrm>
-            <a:off x="9235440" y="3657600"/>
-            <a:ext cx="1371600" cy="640080"/>
-          </a:xfrm>
-          <a:prstGeom prst="rect">
-            <a:avLst/>
-          </a:prstGeom>
-          <a:noFill/>
-        </p:spPr>
-        <p:txBody>
-          <a:bodyPr wrap="square">
-            <a:spAutoFit/>
-          </a:bodyPr>
-          <a:lstStyle/>
-          <a:p>
-            <a:pPr algn="ctr">
-              <a:lnSpc>
-                <a:spcPct val="130000"/>
-              </a:lnSpc>
-              <a:spcBef>
-                <a:spcPts val="0"/>
-              </a:spcBef>
-              <a:spcAft>
-                <a:spcPts val="0"/>
-              </a:spcAft>
-              <a:defRPr sz="1100" b="0">
-                <a:solidFill>
-                  <a:srgbClr val="9A9690"/>
-                </a:solidFill>
-                <a:latin typeface="Calibri"/>
-              </a:defRPr>
-            </a:pPr>
-            <a:r>
-              <a:t>Community</a:t>
-            </a:r>
-            <a:br/>
-            <a:r>
-              <a:t>members</a:t>
-            </a:r>
-          </a:p>
-        </p:txBody>
-      </p:sp>
-      <p:sp>
-        <p:nvSpPr>
-          <p:cNvPr id="18" name="TextBox 17"/>
-          <p:cNvSpPr txBox="1"/>
-          <p:nvPr/>
-        </p:nvSpPr>
-        <p:spPr>
-          <a:xfrm>
-            <a:off x="10698480" y="3017520"/>
-            <a:ext cx="1371600" cy="640080"/>
-          </a:xfrm>
-          <a:prstGeom prst="rect">
-            <a:avLst/>
-          </a:prstGeom>
-          <a:noFill/>
-        </p:spPr>
-        <p:txBody>
-          <a:bodyPr wrap="square">
-            <a:spAutoFit/>
-          </a:bodyPr>
-          <a:lstStyle/>
-          <a:p>
-            <a:pPr algn="ctr">
-              <a:lnSpc>
-                <a:spcPct val="120000"/>
-              </a:lnSpc>
-              <a:spcBef>
-                <a:spcPts val="0"/>
-              </a:spcBef>
-              <a:spcAft>
-                <a:spcPts val="0"/>
-              </a:spcAft>
-              <a:defRPr sz="3600" b="0">
-                <a:solidFill>
-                  <a:srgbClr val="4A7C59"/>
-                </a:solidFill>
-                <a:latin typeface="Georgia"/>
-              </a:defRPr>
-            </a:pPr>
-            <a:r>
-              <a:t>13</a:t>
-            </a:r>
-          </a:p>
-        </p:txBody>
-      </p:sp>
-      <p:sp>
-        <p:nvSpPr>
-          <p:cNvPr id="19" name="TextBox 18"/>
-          <p:cNvSpPr txBox="1"/>
-          <p:nvPr/>
-        </p:nvSpPr>
-        <p:spPr>
-          <a:xfrm>
-            <a:off x="10698480" y="3657600"/>
-            <a:ext cx="1371600" cy="640080"/>
-          </a:xfrm>
-          <a:prstGeom prst="rect">
-            <a:avLst/>
-          </a:prstGeom>
-          <a:noFill/>
-        </p:spPr>
-        <p:txBody>
-          <a:bodyPr wrap="square">
-            <a:spAutoFit/>
-          </a:bodyPr>
-          <a:lstStyle/>
-          <a:p>
-            <a:pPr algn="ctr">
-              <a:lnSpc>
-                <a:spcPct val="130000"/>
-              </a:lnSpc>
-              <a:spcBef>
-                <a:spcPts val="0"/>
-              </a:spcBef>
-              <a:spcAft>
-                <a:spcPts val="0"/>
-              </a:spcAft>
-              <a:defRPr sz="1100" b="0">
-                <a:solidFill>
-                  <a:srgbClr val="9A9690"/>
-                </a:solidFill>
-                <a:latin typeface="Calibri"/>
-              </a:defRPr>
-            </a:pPr>
-            <a:r>
-              <a:t>LVB cohort</a:t>
-            </a:r>
-            <a:br/>
-            <a:r>
-              <a:t>builders</a:t>
+              <a:t>Brand &amp; design</a:t>
             </a:r>
           </a:p>
         </p:txBody>

</xml_diff>

<commit_message>
refine NVC pitch: founder intro, slide 3 closer, bio updates
- Slide 1: add founder credentials (MA Ecopsych, MS Creative Tech, ex-Google, founding eng x2)
- Slide 3: close with "they need a system that learns them"
- Update team bios across exec summary, web deck, and markdown draft

Co-Authored-By: Claude Opus 4.6 <noreply@anthropic.com>
</commit_message>
<xml_diff>
--- a/nvc-pitch-deck.pptx
+++ b/nvc-pitch-deck.pptx
@@ -3211,8 +3211,8 @@
         </p:nvSpPr>
         <p:spPr>
           <a:xfrm>
-            <a:off x="1097280" y="4572000"/>
-            <a:ext cx="7315200" cy="1097280"/>
+            <a:off x="1097280" y="4389120"/>
+            <a:ext cx="7315200" cy="914400"/>
           </a:xfrm>
           <a:prstGeom prst="rect">
             <a:avLst/>
@@ -3268,7 +3268,52 @@
         </p:nvSpPr>
         <p:spPr>
           <a:xfrm>
-            <a:off x="1097280" y="6035040"/>
+            <a:off x="1097280" y="5669280"/>
+            <a:ext cx="9144000" cy="457200"/>
+          </a:xfrm>
+          <a:prstGeom prst="rect">
+            <a:avLst/>
+          </a:prstGeom>
+          <a:noFill/>
+        </p:spPr>
+        <p:txBody>
+          <a:bodyPr wrap="square">
+            <a:spAutoFit/>
+          </a:bodyPr>
+          <a:lstStyle/>
+          <a:p>
+            <a:pPr algn="l">
+              <a:lnSpc>
+                <a:spcPct val="120000"/>
+              </a:lnSpc>
+              <a:spcBef>
+                <a:spcPts val="0"/>
+              </a:spcBef>
+              <a:spcAft>
+                <a:spcPts val="0"/>
+              </a:spcAft>
+              <a:defRPr sz="1300" b="0">
+                <a:solidFill>
+                  <a:srgbClr val="9A9690"/>
+                </a:solidFill>
+                <a:latin typeface="Calibri"/>
+              </a:defRPr>
+            </a:pPr>
+            <a:r>
+              <a:t>MA Ecopsychology · MS Creative Technology &amp; Design (CU ATLAS) · Founding engineer ×2 · Ex-Google · 10+ years full stack</a:t>
+            </a:r>
+          </a:p>
+        </p:txBody>
+      </p:sp>
+      <p:sp>
+        <p:nvSpPr>
+          <p:cNvPr id="6" name="TextBox 5"/>
+          <p:cNvSpPr txBox="1"/>
+          <p:nvPr/>
+        </p:nvSpPr>
+        <p:spPr>
+          <a:xfrm>
+            <a:off x="1097280" y="6126480"/>
             <a:ext cx="5486400" cy="365760"/>
           </a:xfrm>
           <a:prstGeom prst="rect">
@@ -4388,19 +4433,19 @@
               <a:spcAft>
                 <a:spcPts val="0"/>
               </a:spcAft>
-              <a:defRPr sz="2000" b="0">
+              <a:defRPr sz="2200" b="0">
                 <a:solidFill>
                   <a:srgbClr val="2C2A26"/>
                 </a:solidFill>
-                <a:latin typeface="Calibri"/>
+                <a:latin typeface="Georgia"/>
               </a:defRPr>
             </a:pPr>
             <a:r>
-              <a:t>They're not going to adopt a full agentic computer cold.</a:t>
+              <a:t>They need a system that learns them —</a:t>
             </a:r>
             <a:br/>
             <a:r>
-              <a:t>They need a bridge.</a:t>
+              <a:t>not one that demands they learn it.</a:t>
             </a:r>
           </a:p>
         </p:txBody>

</xml_diff>

<commit_message>
refine NVC pitch: pricing, market numbers, framing, close
- Slide 1: "Balance and choice should be built in from the start"
- Market: "Over 100M people pay $20+/mo" (incl 50M+ ChatGPT Pro)
- Pricing: Free → $2 sync → $10 Daily AI → $40 Hosted Computer
- Financial projections updated: ~$10/mo avg, $4.2M ARR by 2028
- Traction: "Bootstrapped. Zero funding." (not solo)
- Close: "Balance and choice — from the foundation"
- All changes across pptx, web deck, exec summary, markdown draft

Co-Authored-By: Claude Opus 4.6 <noreply@anthropic.com>
</commit_message>
<xml_diff>
--- a/nvc-pitch-deck.pptx
+++ b/nvc-pitch-deck.pptx
@@ -3159,7 +3159,7 @@
         </p:nvSpPr>
         <p:spPr>
           <a:xfrm>
-            <a:off x="1097280" y="1828800"/>
+            <a:off x="1097280" y="1645920"/>
             <a:ext cx="9144000" cy="2286000"/>
           </a:xfrm>
           <a:prstGeom prst="rect">
@@ -3183,7 +3183,7 @@
               <a:spcAft>
                 <a:spcPts val="0"/>
               </a:spcAft>
-              <a:defRPr sz="4800" b="0">
+              <a:defRPr sz="4600" b="0">
                 <a:solidFill>
                   <a:srgbClr val="2C2A26"/>
                 </a:solidFill>
@@ -3191,15 +3191,19 @@
               </a:defRPr>
             </a:pPr>
             <a:r>
-              <a:t>Technology should help us</a:t>
+              <a:t>The most powerful technologies</a:t>
             </a:r>
             <a:br/>
             <a:r>
-              <a:t>live fully — not demand</a:t>
+              <a:t>in a generation are emerging.</a:t>
             </a:r>
             <a:br/>
             <a:r>
-              <a:t>we stop living to use it.</a:t>
+              <a:t>Balance and choice should be</a:t>
+            </a:r>
+            <a:br/>
+            <a:r>
+              <a:t>built in from the start.</a:t>
             </a:r>
           </a:p>
         </p:txBody>
@@ -3256,7 +3260,7 @@
             </a:r>
             <a:br/>
             <a:r>
-              <a:t>We shouldn't have to choose.</a:t>
+              <a:t>Technology should support both.</a:t>
             </a:r>
           </a:p>
         </p:txBody>
@@ -3821,7 +3825,7 @@
                         </a:defRPr>
                       </a:pPr>
                       <a:r>
-                        <a:t>~$5/mo</a:t>
+                        <a:t>~$10/mo</a:t>
                       </a:r>
                     </a:p>
                   </a:txBody>
@@ -3845,7 +3849,7 @@
                         </a:defRPr>
                       </a:pPr>
                       <a:r>
-                        <a:t>~$7/mo</a:t>
+                        <a:t>~$12/mo</a:t>
                       </a:r>
                     </a:p>
                   </a:txBody>
@@ -3869,7 +3873,7 @@
                         </a:defRPr>
                       </a:pPr>
                       <a:r>
-                        <a:t>~$8/mo</a:t>
+                        <a:t>~$14/mo</a:t>
                       </a:r>
                     </a:p>
                   </a:txBody>
@@ -3919,7 +3923,7 @@
                         </a:defRPr>
                       </a:pPr>
                       <a:r>
-                        <a:t>~$2,500</a:t>
+                        <a:t>~$5,000</a:t>
                       </a:r>
                     </a:p>
                   </a:txBody>
@@ -3943,7 +3947,7 @@
                         </a:defRPr>
                       </a:pPr>
                       <a:r>
-                        <a:t>~$35,000</a:t>
+                        <a:t>~$60,000</a:t>
                       </a:r>
                     </a:p>
                   </a:txBody>
@@ -3967,7 +3971,7 @@
                         </a:defRPr>
                       </a:pPr>
                       <a:r>
-                        <a:t>~$200,000</a:t>
+                        <a:t>~$350,000</a:t>
                       </a:r>
                     </a:p>
                   </a:txBody>
@@ -4017,7 +4021,7 @@
                         </a:defRPr>
                       </a:pPr>
                       <a:r>
-                        <a:t>~$30K</a:t>
+                        <a:t>~$60K</a:t>
                       </a:r>
                     </a:p>
                   </a:txBody>
@@ -4041,7 +4045,7 @@
                         </a:defRPr>
                       </a:pPr>
                       <a:r>
-                        <a:t>~$420K</a:t>
+                        <a:t>~$720K</a:t>
                       </a:r>
                     </a:p>
                   </a:txBody>
@@ -4065,7 +4069,7 @@
                         </a:defRPr>
                       </a:pPr>
                       <a:r>
-                        <a:t>~$2.4M</a:t>
+                        <a:t>~$4.2M</a:t>
                       </a:r>
                     </a:p>
                   </a:txBody>
@@ -4825,7 +4829,7 @@
           <a:p>
             <a:pPr algn="l">
               <a:lnSpc>
-                <a:spcPct val="120000"/>
+                <a:spcPct val="130000"/>
               </a:lnSpc>
               <a:spcBef>
                 <a:spcPts val="0"/>
@@ -4841,7 +4845,11 @@
               </a:defRPr>
             </a:pPr>
             <a:r>
-              <a:t>I want everyone to be able to hike up that mountain.</a:t>
+              <a:t>Open source. Local-first.</a:t>
+            </a:r>
+            <a:br/>
+            <a:r>
+              <a:t>Balance and choice — from the foundation.</a:t>
             </a:r>
           </a:p>
         </p:txBody>
@@ -5051,7 +5059,7 @@
               </a:defRPr>
             </a:pPr>
             <a:r>
-              <a:t>Hundreds of millions of people already pay $20-200/month for AI tools.</a:t>
+              <a:t>Over 100 million people already pay $20+/month for AI — including 50M+ ChatGPT Pro subscribers.</a:t>
             </a:r>
             <a:br/>
             <a:r>
@@ -7512,7 +7520,7 @@
               </a:defRPr>
             </a:pPr>
             <a:r>
-              <a:t>$1-2/mo</a:t>
+              <a:t>$2/mo</a:t>
             </a:r>
           </a:p>
         </p:txBody>
@@ -7645,7 +7653,7 @@
               </a:defRPr>
             </a:pPr>
             <a:r>
-              <a:t>$5/mo</a:t>
+              <a:t>$10/mo</a:t>
             </a:r>
           </a:p>
         </p:txBody>
@@ -7690,7 +7698,7 @@
               </a:defRPr>
             </a:pPr>
             <a:r>
-              <a:t>Cloud transcription + AI reflections, synthesis, pattern surfacing</a:t>
+              <a:t>Cloud transcription + AI — reflections, synthesis, pattern surfacing</a:t>
             </a:r>
           </a:p>
         </p:txBody>
@@ -7735,7 +7743,7 @@
               </a:defRPr>
             </a:pPr>
             <a:r>
-              <a:t>$20/mo</a:t>
+              <a:t>$40/mo</a:t>
             </a:r>
           </a:p>
         </p:txBody>
@@ -7780,7 +7788,7 @@
               </a:defRPr>
             </a:pPr>
             <a:r>
-              <a:t>Hosted Parachute Computer — full agentic platform</a:t>
+              <a:t>Hosted Parachute Computer — full agentic platform with bundled AI</a:t>
             </a:r>
           </a:p>
         </p:txBody>
@@ -7829,7 +7837,7 @@
             </a:r>
             <a:br/>
             <a:r>
-              <a:t>AI at $5/mo uses cost-efficient models. Margins are real and improve as model costs drop.</a:t>
+              <a:t>AI at $10/mo uses cost-efficient models. Margins are real and improve as model costs drop.</a:t>
             </a:r>
           </a:p>
         </p:txBody>
@@ -7945,11 +7953,11 @@
               </a:defRPr>
             </a:pPr>
             <a:r>
-              <a:t>Built from zero.</a:t>
+              <a:t>Bootstrapped.</a:t>
             </a:r>
             <a:br/>
             <a:r>
-              <a:t>Solo. No funding.</a:t>
+              <a:t>Zero funding.</a:t>
             </a:r>
           </a:p>
         </p:txBody>

</xml_diff>

<commit_message>
refine NVC deck: add $5 tier, realistic COGS, slim self-funded slide
Co-Authored-By: Claude Opus 4.6 <noreply@anthropic.com>
</commit_message>
<xml_diff>
--- a/nvc-pitch-deck.pptx
+++ b/nvc-pitch-deck.pptx
@@ -5304,13 +5304,103 @@
       </p:sp>
       <p:sp>
         <p:nvSpPr>
-          <p:cNvPr id="8" name="Rounded Rectangle 7"/>
+          <p:cNvPr id="8" name="TextBox 7"/>
+          <p:cNvSpPr txBox="1"/>
+          <p:nvPr/>
+        </p:nvSpPr>
+        <p:spPr>
+          <a:xfrm>
+            <a:off x="1097280" y="4480560"/>
+            <a:ext cx="1645920" cy="365760"/>
+          </a:xfrm>
+          <a:prstGeom prst="rect">
+            <a:avLst/>
+          </a:prstGeom>
+          <a:noFill/>
+        </p:spPr>
+        <p:txBody>
+          <a:bodyPr wrap="square">
+            <a:spAutoFit/>
+          </a:bodyPr>
+          <a:lstStyle/>
+          <a:p>
+            <a:pPr algn="l">
+              <a:lnSpc>
+                <a:spcPct val="120000"/>
+              </a:lnSpc>
+              <a:spcBef>
+                <a:spcPts val="0"/>
+              </a:spcBef>
+              <a:spcAft>
+                <a:spcPts val="0"/>
+              </a:spcAft>
+              <a:defRPr sz="2400" b="0">
+                <a:solidFill>
+                  <a:srgbClr val="6B6860"/>
+                </a:solidFill>
+                <a:latin typeface="Georgia"/>
+              </a:defRPr>
+            </a:pPr>
+            <a:r>
+              <a:t>$5/mo</a:t>
+            </a:r>
+          </a:p>
+        </p:txBody>
+      </p:sp>
+      <p:sp>
+        <p:nvSpPr>
+          <p:cNvPr id="9" name="TextBox 8"/>
+          <p:cNvSpPr txBox="1"/>
+          <p:nvPr/>
+        </p:nvSpPr>
+        <p:spPr>
+          <a:xfrm>
+            <a:off x="2926080" y="4526280"/>
+            <a:ext cx="7315200" cy="365760"/>
+          </a:xfrm>
+          <a:prstGeom prst="rect">
+            <a:avLst/>
+          </a:prstGeom>
+          <a:noFill/>
+        </p:spPr>
+        <p:txBody>
+          <a:bodyPr wrap="square">
+            <a:spAutoFit/>
+          </a:bodyPr>
+          <a:lstStyle/>
+          <a:p>
+            <a:pPr algn="l">
+              <a:lnSpc>
+                <a:spcPct val="120000"/>
+              </a:lnSpc>
+              <a:spcBef>
+                <a:spcPts val="0"/>
+              </a:spcBef>
+              <a:spcAft>
+                <a:spcPts val="0"/>
+              </a:spcAft>
+              <a:defRPr sz="1600" b="0">
+                <a:solidFill>
+                  <a:srgbClr val="6B6860"/>
+                </a:solidFill>
+                <a:latin typeface="Calibri"/>
+              </a:defRPr>
+            </a:pPr>
+            <a:r>
+              <a:t>Cloud transcription + cleanup — server-side processing, better accuracy</a:t>
+            </a:r>
+          </a:p>
+        </p:txBody>
+      </p:sp>
+      <p:sp>
+        <p:nvSpPr>
+          <p:cNvPr id="10" name="Rounded Rectangle 9"/>
           <p:cNvSpPr/>
           <p:nvPr/>
         </p:nvSpPr>
         <p:spPr>
           <a:xfrm>
-            <a:off x="914400" y="4343400"/>
+            <a:off x="914400" y="4983480"/>
             <a:ext cx="9601200" cy="594360"/>
           </a:xfrm>
           <a:prstGeom prst="roundRect">
@@ -5347,13 +5437,13 @@
       </p:sp>
       <p:sp>
         <p:nvSpPr>
-          <p:cNvPr id="9" name="TextBox 8"/>
+          <p:cNvPr id="11" name="TextBox 10"/>
           <p:cNvSpPr txBox="1"/>
           <p:nvPr/>
         </p:nvSpPr>
         <p:spPr>
           <a:xfrm>
-            <a:off x="1097280" y="4480560"/>
+            <a:off x="1097280" y="5120640"/>
             <a:ext cx="1645920" cy="365760"/>
           </a:xfrm>
           <a:prstGeom prst="rect">
@@ -5392,13 +5482,13 @@
       </p:sp>
       <p:sp>
         <p:nvSpPr>
-          <p:cNvPr id="10" name="TextBox 9"/>
+          <p:cNvPr id="12" name="TextBox 11"/>
           <p:cNvSpPr txBox="1"/>
           <p:nvPr/>
         </p:nvSpPr>
         <p:spPr>
           <a:xfrm>
-            <a:off x="2926080" y="4526280"/>
+            <a:off x="2926080" y="5166360"/>
             <a:ext cx="7315200" cy="365760"/>
           </a:xfrm>
           <a:prstGeom prst="rect">
@@ -5430,20 +5520,20 @@
               </a:defRPr>
             </a:pPr>
             <a:r>
-              <a:t>Cloud transcription + AI — reflections, synthesis, pattern surfacing</a:t>
-            </a:r>
-          </a:p>
-        </p:txBody>
-      </p:sp>
-      <p:sp>
-        <p:nvSpPr>
-          <p:cNvPr id="11" name="TextBox 10"/>
+              <a:t>AI reflections, synthesis, and pattern surfacing</a:t>
+            </a:r>
+          </a:p>
+        </p:txBody>
+      </p:sp>
+      <p:sp>
+        <p:nvSpPr>
+          <p:cNvPr id="13" name="TextBox 12"/>
           <p:cNvSpPr txBox="1"/>
           <p:nvPr/>
         </p:nvSpPr>
         <p:spPr>
           <a:xfrm>
-            <a:off x="1097280" y="5120640"/>
+            <a:off x="1097280" y="5760720"/>
             <a:ext cx="1645920" cy="365760"/>
           </a:xfrm>
           <a:prstGeom prst="rect">
@@ -5482,13 +5572,13 @@
       </p:sp>
       <p:sp>
         <p:nvSpPr>
-          <p:cNvPr id="12" name="TextBox 11"/>
+          <p:cNvPr id="14" name="TextBox 13"/>
           <p:cNvSpPr txBox="1"/>
           <p:nvPr/>
         </p:nvSpPr>
         <p:spPr>
           <a:xfrm>
-            <a:off x="2926080" y="5166360"/>
+            <a:off x="2926080" y="5806440"/>
             <a:ext cx="7315200" cy="365760"/>
           </a:xfrm>
           <a:prstGeom prst="rect">
@@ -5527,7 +5617,7 @@
       </p:sp>
       <p:sp>
         <p:nvSpPr>
-          <p:cNvPr id="13" name="TextBox 12"/>
+          <p:cNvPr id="15" name="TextBox 14"/>
           <p:cNvSpPr txBox="1"/>
           <p:nvPr/>
         </p:nvSpPr>
@@ -6044,7 +6134,31 @@
                         </a:defRPr>
                       </a:pPr>
                       <a:r>
-                        <a:t>~$10/mo</a:t>
+                        <a:t>~$7/mo</a:t>
+                      </a:r>
+                    </a:p>
+                  </a:txBody>
+                  <a:tcPr>
+                    <a:solidFill>
+                      <a:srgbClr val="FFFFFF"/>
+                    </a:solidFill>
+                  </a:tcPr>
+                </a:tc>
+                <a:tc>
+                  <a:txBody>
+                    <a:bodyPr/>
+                    <a:lstStyle/>
+                    <a:p>
+                      <a:pPr algn="ctr">
+                        <a:defRPr sz="1300">
+                          <a:solidFill>
+                            <a:srgbClr val="6B6860"/>
+                          </a:solidFill>
+                          <a:latin typeface="Calibri"/>
+                        </a:defRPr>
+                      </a:pPr>
+                      <a:r>
+                        <a:t>~$9/mo</a:t>
                       </a:r>
                     </a:p>
                   </a:txBody>
@@ -6078,6 +6192,130 @@
                     </a:solidFill>
                   </a:tcPr>
                 </a:tc>
+              </a:tr>
+              <a:tr h="365760">
+                <a:tc>
+                  <a:txBody>
+                    <a:bodyPr/>
+                    <a:lstStyle/>
+                    <a:p>
+                      <a:pPr algn="l">
+                        <a:defRPr sz="1200" b="1">
+                          <a:solidFill>
+                            <a:srgbClr val="2C2A26"/>
+                          </a:solidFill>
+                          <a:latin typeface="Calibri"/>
+                        </a:defRPr>
+                      </a:pPr>
+                      <a:r>
+                        <a:t>ARR</a:t>
+                      </a:r>
+                    </a:p>
+                  </a:txBody>
+                  <a:tcPr>
+                    <a:solidFill>
+                      <a:srgbClr val="FAF8F4"/>
+                    </a:solidFill>
+                  </a:tcPr>
+                </a:tc>
+                <a:tc>
+                  <a:txBody>
+                    <a:bodyPr/>
+                    <a:lstStyle/>
+                    <a:p>
+                      <a:pPr algn="ctr">
+                        <a:defRPr sz="1300" b="1">
+                          <a:solidFill>
+                            <a:srgbClr val="4A7C59"/>
+                          </a:solidFill>
+                          <a:latin typeface="Calibri"/>
+                        </a:defRPr>
+                      </a:pPr>
+                      <a:r>
+                        <a:t>~$42K</a:t>
+                      </a:r>
+                    </a:p>
+                  </a:txBody>
+                  <a:tcPr>
+                    <a:solidFill>
+                      <a:srgbClr val="FAF8F4"/>
+                    </a:solidFill>
+                  </a:tcPr>
+                </a:tc>
+                <a:tc>
+                  <a:txBody>
+                    <a:bodyPr/>
+                    <a:lstStyle/>
+                    <a:p>
+                      <a:pPr algn="ctr">
+                        <a:defRPr sz="1300" b="1">
+                          <a:solidFill>
+                            <a:srgbClr val="4A7C59"/>
+                          </a:solidFill>
+                          <a:latin typeface="Calibri"/>
+                        </a:defRPr>
+                      </a:pPr>
+                      <a:r>
+                        <a:t>~$540K</a:t>
+                      </a:r>
+                    </a:p>
+                  </a:txBody>
+                  <a:tcPr>
+                    <a:solidFill>
+                      <a:srgbClr val="FAF8F4"/>
+                    </a:solidFill>
+                  </a:tcPr>
+                </a:tc>
+                <a:tc>
+                  <a:txBody>
+                    <a:bodyPr/>
+                    <a:lstStyle/>
+                    <a:p>
+                      <a:pPr algn="ctr">
+                        <a:defRPr sz="1300" b="1">
+                          <a:solidFill>
+                            <a:srgbClr val="4A7C59"/>
+                          </a:solidFill>
+                          <a:latin typeface="Calibri"/>
+                        </a:defRPr>
+                      </a:pPr>
+                      <a:r>
+                        <a:t>~$3.6M</a:t>
+                      </a:r>
+                    </a:p>
+                  </a:txBody>
+                  <a:tcPr>
+                    <a:solidFill>
+                      <a:srgbClr val="FAF8F4"/>
+                    </a:solidFill>
+                  </a:tcPr>
+                </a:tc>
+              </a:tr>
+              <a:tr h="365760">
+                <a:tc>
+                  <a:txBody>
+                    <a:bodyPr/>
+                    <a:lstStyle/>
+                    <a:p>
+                      <a:pPr algn="l">
+                        <a:defRPr sz="1200" b="1">
+                          <a:solidFill>
+                            <a:srgbClr val="2C2A26"/>
+                          </a:solidFill>
+                          <a:latin typeface="Calibri"/>
+                        </a:defRPr>
+                      </a:pPr>
+                      <a:r>
+                        <a:t>Team costs</a:t>
+                      </a:r>
+                    </a:p>
+                  </a:txBody>
+                  <a:tcPr>
+                    <a:solidFill>
+                      <a:srgbClr val="FFFFFF"/>
+                    </a:solidFill>
+                  </a:tcPr>
+                </a:tc>
                 <a:tc>
                   <a:txBody>
                     <a:bodyPr/>
@@ -6092,7 +6330,55 @@
                         </a:defRPr>
                       </a:pPr>
                       <a:r>
-                        <a:t>~$14/mo</a:t>
+                        <a:t>~$150K</a:t>
+                      </a:r>
+                    </a:p>
+                  </a:txBody>
+                  <a:tcPr>
+                    <a:solidFill>
+                      <a:srgbClr val="FFFFFF"/>
+                    </a:solidFill>
+                  </a:tcPr>
+                </a:tc>
+                <a:tc>
+                  <a:txBody>
+                    <a:bodyPr/>
+                    <a:lstStyle/>
+                    <a:p>
+                      <a:pPr algn="ctr">
+                        <a:defRPr sz="1300">
+                          <a:solidFill>
+                            <a:srgbClr val="6B6860"/>
+                          </a:solidFill>
+                          <a:latin typeface="Calibri"/>
+                        </a:defRPr>
+                      </a:pPr>
+                      <a:r>
+                        <a:t>~$400K</a:t>
+                      </a:r>
+                    </a:p>
+                  </a:txBody>
+                  <a:tcPr>
+                    <a:solidFill>
+                      <a:srgbClr val="FFFFFF"/>
+                    </a:solidFill>
+                  </a:tcPr>
+                </a:tc>
+                <a:tc>
+                  <a:txBody>
+                    <a:bodyPr/>
+                    <a:lstStyle/>
+                    <a:p>
+                      <a:pPr algn="ctr">
+                        <a:defRPr sz="1300">
+                          <a:solidFill>
+                            <a:srgbClr val="6B6860"/>
+                          </a:solidFill>
+                          <a:latin typeface="Calibri"/>
+                        </a:defRPr>
+                      </a:pPr>
+                      <a:r>
+                        <a:t>~$800K</a:t>
                       </a:r>
                     </a:p>
                   </a:txBody>
@@ -6118,7 +6404,7 @@
                         </a:defRPr>
                       </a:pPr>
                       <a:r>
-                        <a:t>MRR (end of year)</a:t>
+                        <a:t>Infra + COGS</a:t>
                       </a:r>
                     </a:p>
                   </a:txBody>
@@ -6142,7 +6428,7 @@
                         </a:defRPr>
                       </a:pPr>
                       <a:r>
-                        <a:t>~$5,000</a:t>
+                        <a:t>~$15K</a:t>
                       </a:r>
                     </a:p>
                   </a:txBody>
@@ -6166,7 +6452,7 @@
                         </a:defRPr>
                       </a:pPr>
                       <a:r>
-                        <a:t>~$60,000</a:t>
+                        <a:t>~$130K</a:t>
                       </a:r>
                     </a:p>
                   </a:txBody>
@@ -6190,7 +6476,7 @@
                         </a:defRPr>
                       </a:pPr>
                       <a:r>
-                        <a:t>~$350,000</a:t>
+                        <a:t>~$500K</a:t>
                       </a:r>
                     </a:p>
                   </a:txBody>
@@ -6216,203 +6502,7 @@
                         </a:defRPr>
                       </a:pPr>
                       <a:r>
-                        <a:t>ARR (end of year)</a:t>
-                      </a:r>
-                    </a:p>
-                  </a:txBody>
-                  <a:tcPr>
-                    <a:solidFill>
-                      <a:srgbClr val="FFFFFF"/>
-                    </a:solidFill>
-                  </a:tcPr>
-                </a:tc>
-                <a:tc>
-                  <a:txBody>
-                    <a:bodyPr/>
-                    <a:lstStyle/>
-                    <a:p>
-                      <a:pPr algn="ctr">
-                        <a:defRPr sz="1300" b="1">
-                          <a:solidFill>
-                            <a:srgbClr val="4A7C59"/>
-                          </a:solidFill>
-                          <a:latin typeface="Calibri"/>
-                        </a:defRPr>
-                      </a:pPr>
-                      <a:r>
-                        <a:t>~$60K</a:t>
-                      </a:r>
-                    </a:p>
-                  </a:txBody>
-                  <a:tcPr>
-                    <a:solidFill>
-                      <a:srgbClr val="FFFFFF"/>
-                    </a:solidFill>
-                  </a:tcPr>
-                </a:tc>
-                <a:tc>
-                  <a:txBody>
-                    <a:bodyPr/>
-                    <a:lstStyle/>
-                    <a:p>
-                      <a:pPr algn="ctr">
-                        <a:defRPr sz="1300" b="1">
-                          <a:solidFill>
-                            <a:srgbClr val="4A7C59"/>
-                          </a:solidFill>
-                          <a:latin typeface="Calibri"/>
-                        </a:defRPr>
-                      </a:pPr>
-                      <a:r>
-                        <a:t>~$720K</a:t>
-                      </a:r>
-                    </a:p>
-                  </a:txBody>
-                  <a:tcPr>
-                    <a:solidFill>
-                      <a:srgbClr val="FFFFFF"/>
-                    </a:solidFill>
-                  </a:tcPr>
-                </a:tc>
-                <a:tc>
-                  <a:txBody>
-                    <a:bodyPr/>
-                    <a:lstStyle/>
-                    <a:p>
-                      <a:pPr algn="ctr">
-                        <a:defRPr sz="1300" b="1">
-                          <a:solidFill>
-                            <a:srgbClr val="4A7C59"/>
-                          </a:solidFill>
-                          <a:latin typeface="Calibri"/>
-                        </a:defRPr>
-                      </a:pPr>
-                      <a:r>
-                        <a:t>~$4.2M</a:t>
-                      </a:r>
-                    </a:p>
-                  </a:txBody>
-                  <a:tcPr>
-                    <a:solidFill>
-                      <a:srgbClr val="FFFFFF"/>
-                    </a:solidFill>
-                  </a:tcPr>
-                </a:tc>
-              </a:tr>
-              <a:tr h="365760">
-                <a:tc>
-                  <a:txBody>
-                    <a:bodyPr/>
-                    <a:lstStyle/>
-                    <a:p>
-                      <a:pPr algn="l">
-                        <a:defRPr sz="1200" b="1">
-                          <a:solidFill>
-                            <a:srgbClr val="2C2A26"/>
-                          </a:solidFill>
-                          <a:latin typeface="Calibri"/>
-                        </a:defRPr>
-                      </a:pPr>
-                      <a:r>
-                        <a:t>Team (salaried)</a:t>
-                      </a:r>
-                    </a:p>
-                  </a:txBody>
-                  <a:tcPr>
-                    <a:solidFill>
-                      <a:srgbClr val="FAF8F4"/>
-                    </a:solidFill>
-                  </a:tcPr>
-                </a:tc>
-                <a:tc>
-                  <a:txBody>
-                    <a:bodyPr/>
-                    <a:lstStyle/>
-                    <a:p>
-                      <a:pPr algn="ctr">
-                        <a:defRPr sz="1300">
-                          <a:solidFill>
-                            <a:srgbClr val="6B6860"/>
-                          </a:solidFill>
-                          <a:latin typeface="Calibri"/>
-                        </a:defRPr>
-                      </a:pPr>
-                      <a:r>
-                        <a:t>3</a:t>
-                      </a:r>
-                    </a:p>
-                  </a:txBody>
-                  <a:tcPr>
-                    <a:solidFill>
-                      <a:srgbClr val="FAF8F4"/>
-                    </a:solidFill>
-                  </a:tcPr>
-                </a:tc>
-                <a:tc>
-                  <a:txBody>
-                    <a:bodyPr/>
-                    <a:lstStyle/>
-                    <a:p>
-                      <a:pPr algn="ctr">
-                        <a:defRPr sz="1300">
-                          <a:solidFill>
-                            <a:srgbClr val="6B6860"/>
-                          </a:solidFill>
-                          <a:latin typeface="Calibri"/>
-                        </a:defRPr>
-                      </a:pPr>
-                      <a:r>
-                        <a:t>5-6</a:t>
-                      </a:r>
-                    </a:p>
-                  </a:txBody>
-                  <a:tcPr>
-                    <a:solidFill>
-                      <a:srgbClr val="FAF8F4"/>
-                    </a:solidFill>
-                  </a:tcPr>
-                </a:tc>
-                <a:tc>
-                  <a:txBody>
-                    <a:bodyPr/>
-                    <a:lstStyle/>
-                    <a:p>
-                      <a:pPr algn="ctr">
-                        <a:defRPr sz="1300">
-                          <a:solidFill>
-                            <a:srgbClr val="6B6860"/>
-                          </a:solidFill>
-                          <a:latin typeface="Calibri"/>
-                        </a:defRPr>
-                      </a:pPr>
-                      <a:r>
-                        <a:t>9-10</a:t>
-                      </a:r>
-                    </a:p>
-                  </a:txBody>
-                  <a:tcPr>
-                    <a:solidFill>
-                      <a:srgbClr val="FAF8F4"/>
-                    </a:solidFill>
-                  </a:tcPr>
-                </a:tc>
-              </a:tr>
-              <a:tr h="365760">
-                <a:tc>
-                  <a:txBody>
-                    <a:bodyPr/>
-                    <a:lstStyle/>
-                    <a:p>
-                      <a:pPr algn="l">
-                        <a:defRPr sz="1200" b="1">
-                          <a:solidFill>
-                            <a:srgbClr val="2C2A26"/>
-                          </a:solidFill>
-                          <a:latin typeface="Calibri"/>
-                        </a:defRPr>
-                      </a:pPr>
-                      <a:r>
-                        <a:t>Operating costs</a:t>
+                        <a:t>Total opex</a:t>
                       </a:r>
                     </a:p>
                   </a:txBody>
@@ -6436,7 +6526,7 @@
                         </a:defRPr>
                       </a:pPr>
                       <a:r>
-                        <a:t>~$170K</a:t>
+                        <a:t>~$165K</a:t>
                       </a:r>
                     </a:p>
                   </a:txBody>
@@ -6460,7 +6550,7 @@
                         </a:defRPr>
                       </a:pPr>
                       <a:r>
-                        <a:t>~$550K</a:t>
+                        <a:t>~$530K</a:t>
                       </a:r>
                     </a:p>
                   </a:txBody>
@@ -6484,7 +6574,7 @@
                         </a:defRPr>
                       </a:pPr>
                       <a:r>
-                        <a:t>~$900K</a:t>
+                        <a:t>~$1.3M</a:t>
                       </a:r>
                     </a:p>
                   </a:txBody>
@@ -6628,7 +6718,7 @@
         <p:spPr>
           <a:xfrm>
             <a:off x="1097280" y="3200400"/>
-            <a:ext cx="5029200" cy="2743200"/>
+            <a:ext cx="5029200" cy="2286000"/>
           </a:xfrm>
           <a:prstGeom prst="rect">
             <a:avLst/>
@@ -6664,31 +6754,19 @@
             <a:br/>
             <a:br/>
             <a:r>
-              <a:t>  ·  Working server, app, and graph-native memory</a:t>
+              <a:t>  ·  Working app with local voice transcription + graph-native memory</a:t>
             </a:r>
             <a:br/>
             <a:r>
-              <a:t>  ·  Local voice transcription (fully offline)</a:t>
+              <a:t>  ·  Multi-platform: phone, Telegram, Discord, Matrix</a:t>
             </a:r>
             <a:br/>
             <a:r>
-              <a:t>  ·  Multi-agent system with trust tiers</a:t>
+              <a:t>  ·  Functional pendant prototype (on stage today)</a:t>
             </a:r>
             <a:br/>
             <a:r>
-              <a:t>  ·  Telegram, Discord, Matrix connectors</a:t>
-            </a:r>
-            <a:br/>
-            <a:r>
-              <a:t>  ·  Functional pendant prototype</a:t>
-            </a:r>
-            <a:br/>
-            <a:r>
-              <a:t>  ·  Beta launching next month</a:t>
-            </a:r>
-            <a:br/>
-            <a:r>
-              <a:t>  ·  PBC incorporated in Colorado</a:t>
+              <a:t>  ·  Daily beta launching this month · PBC incorporated in Colorado</a:t>
             </a:r>
           </a:p>
         </p:txBody>

</xml_diff>

<commit_message>
update deck: tagline, bio, LVB traction, phone number
Syncs web deck and PPTX with exec summary changes:
- "A memory layer for humans and AI to think and remember together"
- MS graduating May 2026
- LVB as organic growth channel
- Phone: (513) 593-1721

Co-Authored-By: Claude Opus 4.6 <noreply@anthropic.com>
</commit_message>
<xml_diff>
--- a/nvc-pitch-deck.pptx
+++ b/nvc-pitch-deck.pptx
@@ -8692,7 +8692,97 @@
       </p:sp>
       <p:sp>
         <p:nvSpPr>
-          <p:cNvPr id="14" name="Rounded Rectangle 13"/>
+          <p:cNvPr id="14" name="TextBox 13"/>
+          <p:cNvSpPr txBox="1"/>
+          <p:nvPr/>
+        </p:nvSpPr>
+        <p:spPr>
+          <a:xfrm>
+            <a:off x="1188720" y="5138928"/>
+            <a:ext cx="274320" cy="274320"/>
+          </a:xfrm>
+          <a:prstGeom prst="rect">
+            <a:avLst/>
+          </a:prstGeom>
+          <a:noFill/>
+        </p:spPr>
+        <p:txBody>
+          <a:bodyPr wrap="square">
+            <a:spAutoFit/>
+          </a:bodyPr>
+          <a:lstStyle/>
+          <a:p>
+            <a:pPr algn="l">
+              <a:lnSpc>
+                <a:spcPct val="120000"/>
+              </a:lnSpc>
+              <a:spcBef>
+                <a:spcPts val="0"/>
+              </a:spcBef>
+              <a:spcAft>
+                <a:spcPts val="0"/>
+              </a:spcAft>
+              <a:defRPr sz="1400" b="0">
+                <a:solidFill>
+                  <a:srgbClr val="4A7C59"/>
+                </a:solidFill>
+                <a:latin typeface="Calibri"/>
+              </a:defRPr>
+            </a:pPr>
+            <a:r>
+              <a:t>•</a:t>
+            </a:r>
+          </a:p>
+        </p:txBody>
+      </p:sp>
+      <p:sp>
+        <p:nvSpPr>
+          <p:cNvPr id="15" name="TextBox 14"/>
+          <p:cNvSpPr txBox="1"/>
+          <p:nvPr/>
+        </p:nvSpPr>
+        <p:spPr>
+          <a:xfrm>
+            <a:off x="1554480" y="5120640"/>
+            <a:ext cx="4572000" cy="365760"/>
+          </a:xfrm>
+          <a:prstGeom prst="rect">
+            <a:avLst/>
+          </a:prstGeom>
+          <a:noFill/>
+        </p:spPr>
+        <p:txBody>
+          <a:bodyPr wrap="square">
+            <a:spAutoFit/>
+          </a:bodyPr>
+          <a:lstStyle/>
+          <a:p>
+            <a:pPr algn="l">
+              <a:lnSpc>
+                <a:spcPct val="130000"/>
+              </a:lnSpc>
+              <a:spcBef>
+                <a:spcPts val="0"/>
+              </a:spcBef>
+              <a:spcAft>
+                <a:spcPts val="0"/>
+              </a:spcAft>
+              <a:defRPr sz="1500" b="0">
+                <a:solidFill>
+                  <a:srgbClr val="6B6860"/>
+                </a:solidFill>
+                <a:latin typeface="Calibri"/>
+              </a:defRPr>
+            </a:pPr>
+            <a:r>
+              <a:t>Learn Vibe Build AI school (Cohort 0 complete, Cohort 1 launching) — organic growth channel</a:t>
+            </a:r>
+          </a:p>
+        </p:txBody>
+      </p:sp>
+      <p:sp>
+        <p:nvSpPr>
+          <p:cNvPr id="16" name="Rounded Rectangle 15"/>
           <p:cNvSpPr/>
           <p:nvPr/>
         </p:nvSpPr>
@@ -8737,7 +8827,7 @@
       </p:sp>
       <p:sp>
         <p:nvSpPr>
-          <p:cNvPr id="15" name="TextBox 14"/>
+          <p:cNvPr id="17" name="TextBox 16"/>
           <p:cNvSpPr txBox="1"/>
           <p:nvPr/>
         </p:nvSpPr>
@@ -8782,7 +8872,7 @@
       </p:sp>
       <p:sp>
         <p:nvSpPr>
-          <p:cNvPr id="16" name="TextBox 15"/>
+          <p:cNvPr id="18" name="TextBox 17"/>
           <p:cNvSpPr txBox="1"/>
           <p:nvPr/>
         </p:nvSpPr>
@@ -8827,7 +8917,7 @@
       </p:sp>
       <p:sp>
         <p:nvSpPr>
-          <p:cNvPr id="17" name="TextBox 16"/>
+          <p:cNvPr id="19" name="TextBox 18"/>
           <p:cNvSpPr txBox="1"/>
           <p:nvPr/>
         </p:nvSpPr>
@@ -8872,7 +8962,7 @@
       </p:sp>
       <p:sp>
         <p:nvSpPr>
-          <p:cNvPr id="18" name="TextBox 17"/>
+          <p:cNvPr id="20" name="TextBox 19"/>
           <p:cNvSpPr txBox="1"/>
           <p:nvPr/>
         </p:nvSpPr>
@@ -8917,7 +9007,7 @@
       </p:sp>
       <p:sp>
         <p:nvSpPr>
-          <p:cNvPr id="19" name="TextBox 18"/>
+          <p:cNvPr id="21" name="TextBox 20"/>
           <p:cNvSpPr txBox="1"/>
           <p:nvPr/>
         </p:nvSpPr>
@@ -8962,7 +9052,7 @@
       </p:sp>
       <p:sp>
         <p:nvSpPr>
-          <p:cNvPr id="20" name="TextBox 19"/>
+          <p:cNvPr id="22" name="TextBox 21"/>
           <p:cNvSpPr txBox="1"/>
           <p:nvPr/>
         </p:nvSpPr>
@@ -9007,7 +9097,7 @@
       </p:sp>
       <p:sp>
         <p:nvSpPr>
-          <p:cNvPr id="21" name="TextBox 20"/>
+          <p:cNvPr id="23" name="TextBox 22"/>
           <p:cNvSpPr txBox="1"/>
           <p:nvPr/>
         </p:nvSpPr>
@@ -9052,7 +9142,7 @@
       </p:sp>
       <p:sp>
         <p:nvSpPr>
-          <p:cNvPr id="22" name="TextBox 21"/>
+          <p:cNvPr id="24" name="TextBox 23"/>
           <p:cNvSpPr txBox="1"/>
           <p:nvPr/>
         </p:nvSpPr>
@@ -9097,7 +9187,7 @@
       </p:sp>
       <p:sp>
         <p:nvSpPr>
-          <p:cNvPr id="23" name="TextBox 22"/>
+          <p:cNvPr id="25" name="TextBox 24"/>
           <p:cNvSpPr txBox="1"/>
           <p:nvPr/>
         </p:nvSpPr>
@@ -9142,7 +9232,7 @@
       </p:sp>
       <p:sp>
         <p:nvSpPr>
-          <p:cNvPr id="24" name="TextBox 23"/>
+          <p:cNvPr id="26" name="TextBox 25"/>
           <p:cNvSpPr txBox="1"/>
           <p:nvPr/>
         </p:nvSpPr>
@@ -9187,7 +9277,7 @@
       </p:sp>
       <p:sp>
         <p:nvSpPr>
-          <p:cNvPr id="25" name="TextBox 24"/>
+          <p:cNvPr id="27" name="TextBox 26"/>
           <p:cNvSpPr txBox="1"/>
           <p:nvPr/>
         </p:nvSpPr>
@@ -9232,7 +9322,7 @@
       </p:sp>
       <p:sp>
         <p:nvSpPr>
-          <p:cNvPr id="26" name="TextBox 25"/>
+          <p:cNvPr id="28" name="TextBox 27"/>
           <p:cNvSpPr txBox="1"/>
           <p:nvPr/>
         </p:nvSpPr>
@@ -9270,7 +9360,7 @@
               </a:defRPr>
             </a:pPr>
             <a:r>
-              <a:t>MA Ecopsychology · MS Creative Technology &amp; Design (CU ATLAS) · Founding engineer ×2 · Ex-Google · 10+ years full stack</a:t>
+              <a:t>MA Ecopsychology · MS Creative Technology &amp; Design (CU ATLAS, graduating May 2026) · Founding engineer ×2 · Ex-Google · 10+ years full stack</a:t>
             </a:r>
           </a:p>
         </p:txBody>
@@ -9469,7 +9559,7 @@
             </a:r>
             <a:br/>
             <a:r>
-              <a:t>the personal data layer.</a:t>
+              <a:t>the memory layer.</a:t>
             </a:r>
           </a:p>
         </p:txBody>
@@ -9829,11 +9919,11 @@
               </a:defRPr>
             </a:pPr>
             <a:r>
-              <a:t>Don’t compete with agents.</a:t>
+              <a:t>A memory layer for humans and AI</a:t>
             </a:r>
             <a:br/>
             <a:r>
-              <a:t>Build what they all need.</a:t>
+              <a:t>to think and remember together.</a:t>
             </a:r>
           </a:p>
         </p:txBody>
@@ -9878,7 +9968,7 @@
               </a:defRPr>
             </a:pPr>
             <a:r>
-              <a:t>Aaron Gabriel Neyer  ·  aaron@parachute.computer  ·  Boulder, CO</a:t>
+              <a:t>Aaron Gabriel Neyer  ·  aaron@parachute.computer  ·  (513) 593-1721  ·  Boulder, CO</a:t>
             </a:r>
           </a:p>
         </p:txBody>

</xml_diff>

<commit_message>
fix slide 4 overlapping text, tighten slide 8 bullet spacing
- Slide 4: narrowed left text column, repositioned arch diagram
  to prevent overlap, single-line thesis at bottom
- Slide 8: reduced bullet font/spacing for 5 items to fit

Co-Authored-By: Claude Opus 4.6 <noreply@anthropic.com>
</commit_message>
<xml_diff>
--- a/nvc-pitch-deck.pptx
+++ b/nvc-pitch-deck.pptx
@@ -4438,7 +4438,7 @@
         <p:spPr>
           <a:xfrm>
             <a:off x="1097280" y="3200400"/>
-            <a:ext cx="5029200" cy="1371600"/>
+            <a:ext cx="4754880" cy="1097280"/>
           </a:xfrm>
           <a:prstGeom prst="rect">
             <a:avLst/>
@@ -4453,7 +4453,7 @@
           <a:p>
             <a:pPr algn="l">
               <a:lnSpc>
-                <a:spcPct val="150000"/>
+                <a:spcPct val="145000"/>
               </a:lnSpc>
               <a:spcBef>
                 <a:spcPts val="0"/>
@@ -4461,7 +4461,7 @@
               <a:spcAft>
                 <a:spcPts val="0"/>
               </a:spcAft>
-              <a:defRPr sz="1800" b="0">
+              <a:defRPr sz="1600" b="0">
                 <a:solidFill>
                   <a:srgbClr val="6B6860"/>
                 </a:solidFill>
@@ -4469,20 +4469,19 @@
               </a:defRPr>
             </a:pPr>
             <a:r>
-              <a:t>Your data lives in a graph database organized around</a:t>
+              <a:t>Your data lives in a graph database organized</a:t>
             </a:r>
             <a:br/>
             <a:r>
-              <a:t>three primitives: Things, Tags, and Tools.</a:t>
+              <a:t>around three primitives: Things, Tags, and Tools.</a:t>
             </a:r>
             <a:br/>
+            <a:r>
+              <a:t>The system speaks MCP — the open standard for</a:t>
+            </a:r>
             <a:br/>
             <a:r>
-              <a:t>The whole system speaks MCP — the open standard</a:t>
-            </a:r>
-            <a:br/>
-            <a:r>
-              <a:t>for connecting AI to tools.</a:t>
+              <a:t>connecting AI to tools.</a:t>
             </a:r>
           </a:p>
         </p:txBody>
@@ -4495,8 +4494,8 @@
         </p:nvSpPr>
         <p:spPr>
           <a:xfrm>
-            <a:off x="1097280" y="4846320"/>
-            <a:ext cx="5029200" cy="914400"/>
+            <a:off x="1097280" y="4480560"/>
+            <a:ext cx="4754880" cy="822960"/>
           </a:xfrm>
           <a:prstGeom prst="rect">
             <a:avLst/>
@@ -4511,7 +4510,7 @@
           <a:p>
             <a:pPr algn="l">
               <a:lnSpc>
-                <a:spcPct val="150000"/>
+                <a:spcPct val="145000"/>
               </a:lnSpc>
               <a:spcBef>
                 <a:spcPts val="0"/>
@@ -4519,7 +4518,7 @@
               <a:spcAft>
                 <a:spcPts val="0"/>
               </a:spcAft>
-              <a:defRPr sz="1600" b="0">
+              <a:defRPr sz="1500" b="0">
                 <a:solidFill>
                   <a:srgbClr val="6B6860"/>
                 </a:solidFill>
@@ -4531,7 +4530,11 @@
             </a:r>
             <a:br/>
             <a:r>
-              <a:t>People nodes. Project nodes. A living knowledge graph.</a:t>
+              <a:t>People nodes. Project nodes.</a:t>
+            </a:r>
+            <a:br/>
+            <a:r>
+              <a:t>A living knowledge graph.</a:t>
             </a:r>
           </a:p>
         </p:txBody>
@@ -4544,8 +4547,8 @@
         </p:nvSpPr>
         <p:spPr>
           <a:xfrm>
-            <a:off x="6858000" y="2743200"/>
-            <a:ext cx="4572000" cy="3657600"/>
+            <a:off x="6400800" y="2743200"/>
+            <a:ext cx="5029200" cy="3474720"/>
           </a:xfrm>
           <a:prstGeom prst="roundRect">
             <a:avLst/>
@@ -4589,8 +4592,8 @@
         </p:nvSpPr>
         <p:spPr>
           <a:xfrm>
-            <a:off x="7223760" y="2926080"/>
-            <a:ext cx="3657600" cy="274320"/>
+            <a:off x="6766560" y="2926080"/>
+            <a:ext cx="4114800" cy="274320"/>
           </a:xfrm>
           <a:prstGeom prst="rect">
             <a:avLst/>
@@ -4634,8 +4637,8 @@
         </p:nvSpPr>
         <p:spPr>
           <a:xfrm>
-            <a:off x="7223760" y="3200400"/>
-            <a:ext cx="3657600" cy="365760"/>
+            <a:off x="6766560" y="3200400"/>
+            <a:ext cx="4114800" cy="365760"/>
           </a:xfrm>
           <a:prstGeom prst="rect">
             <a:avLst/>
@@ -4679,7 +4682,7 @@
         </p:nvSpPr>
         <p:spPr>
           <a:xfrm>
-            <a:off x="8686800" y="3611880"/>
+            <a:off x="8412480" y="3566160"/>
             <a:ext cx="914400" cy="274320"/>
           </a:xfrm>
           <a:prstGeom prst="rect">
@@ -4724,8 +4727,8 @@
         </p:nvSpPr>
         <p:spPr>
           <a:xfrm>
-            <a:off x="7223760" y="3931920"/>
-            <a:ext cx="3657600" cy="274320"/>
+            <a:off x="6766560" y="3840480"/>
+            <a:ext cx="4114800" cy="274320"/>
           </a:xfrm>
           <a:prstGeom prst="rect">
             <a:avLst/>
@@ -4769,8 +4772,8 @@
         </p:nvSpPr>
         <p:spPr>
           <a:xfrm>
-            <a:off x="7132320" y="4160520"/>
-            <a:ext cx="4023360" cy="502920"/>
+            <a:off x="6675120" y="4069080"/>
+            <a:ext cx="4389120" cy="457200"/>
           </a:xfrm>
           <a:prstGeom prst="roundRect">
             <a:avLst/>
@@ -4814,8 +4817,8 @@
         </p:nvSpPr>
         <p:spPr>
           <a:xfrm>
-            <a:off x="7315200" y="4206240"/>
-            <a:ext cx="3657600" cy="365760"/>
+            <a:off x="6858000" y="4114800"/>
+            <a:ext cx="4114800" cy="365760"/>
           </a:xfrm>
           <a:prstGeom prst="rect">
             <a:avLst/>
@@ -4859,7 +4862,7 @@
         </p:nvSpPr>
         <p:spPr>
           <a:xfrm>
-            <a:off x="8412480" y="4709160"/>
+            <a:off x="8229600" y="4572000"/>
             <a:ext cx="1371600" cy="274320"/>
           </a:xfrm>
           <a:prstGeom prst="rect">
@@ -4904,8 +4907,8 @@
         </p:nvSpPr>
         <p:spPr>
           <a:xfrm>
-            <a:off x="7223760" y="5029200"/>
-            <a:ext cx="3657600" cy="274320"/>
+            <a:off x="6766560" y="4846320"/>
+            <a:ext cx="4114800" cy="274320"/>
           </a:xfrm>
           <a:prstGeom prst="rect">
             <a:avLst/>
@@ -4949,8 +4952,8 @@
         </p:nvSpPr>
         <p:spPr>
           <a:xfrm>
-            <a:off x="7223760" y="5303520"/>
-            <a:ext cx="3657600" cy="365760"/>
+            <a:off x="6766560" y="5120640"/>
+            <a:ext cx="4114800" cy="365760"/>
           </a:xfrm>
           <a:prstGeom prst="rect">
             <a:avLst/>
@@ -4995,7 +4998,7 @@
         <p:spPr>
           <a:xfrm>
             <a:off x="1097280" y="5760720"/>
-            <a:ext cx="9144000" cy="548640"/>
+            <a:ext cx="10058400" cy="548640"/>
           </a:xfrm>
           <a:prstGeom prst="rect">
             <a:avLst/>
@@ -5010,7 +5013,7 @@
           <a:p>
             <a:pPr algn="l">
               <a:lnSpc>
-                <a:spcPct val="130000"/>
+                <a:spcPct val="120000"/>
               </a:lnSpc>
               <a:spcBef>
                 <a:spcPts val="0"/>
@@ -5018,7 +5021,7 @@
               <a:spcAft>
                 <a:spcPts val="0"/>
               </a:spcAft>
-              <a:defRPr sz="2000" b="0">
+              <a:defRPr sz="1800" b="0">
                 <a:solidFill>
                   <a:srgbClr val="2C2A26"/>
                 </a:solidFill>
@@ -5026,11 +5029,7 @@
               </a:defRPr>
             </a:pPr>
             <a:r>
-              <a:t>We’re not trying to build the most intelligent tool.</a:t>
-            </a:r>
-            <a:br/>
-            <a:r>
-              <a:t>We’re building the most important tool for intelligent systems to use.</a:t>
+              <a:t>We’re not trying to build the most intelligent tool. We’re building the most important tool for intelligent systems to use.</a:t>
             </a:r>
           </a:p>
         </p:txBody>
@@ -8362,7 +8361,7 @@
               <a:spcAft>
                 <a:spcPts val="0"/>
               </a:spcAft>
-              <a:defRPr sz="1400" b="0">
+              <a:defRPr sz="1200" b="0">
                 <a:solidFill>
                   <a:srgbClr val="4A7C59"/>
                 </a:solidFill>
@@ -8384,52 +8383,7 @@
         <p:spPr>
           <a:xfrm>
             <a:off x="1554480" y="3291840"/>
-            <a:ext cx="4572000" cy="365760"/>
-          </a:xfrm>
-          <a:prstGeom prst="rect">
-            <a:avLst/>
-          </a:prstGeom>
-          <a:noFill/>
-        </p:spPr>
-        <p:txBody>
-          <a:bodyPr wrap="square">
-            <a:spAutoFit/>
-          </a:bodyPr>
-          <a:lstStyle/>
-          <a:p>
-            <a:pPr algn="l">
-              <a:lnSpc>
-                <a:spcPct val="130000"/>
-              </a:lnSpc>
-              <a:spcBef>
-                <a:spcPts val="0"/>
-              </a:spcBef>
-              <a:spcAft>
-                <a:spcPts val="0"/>
-              </a:spcAft>
-              <a:defRPr sz="1500" b="0">
-                <a:solidFill>
-                  <a:srgbClr val="6B6860"/>
-                </a:solidFill>
-                <a:latin typeface="Calibri"/>
-              </a:defRPr>
-            </a:pPr>
-            <a:r>
-              <a:t>Working app with local voice transcription + graph-native storage</a:t>
-            </a:r>
-          </a:p>
-        </p:txBody>
-      </p:sp>
-      <p:sp>
-        <p:nvSpPr>
-          <p:cNvPr id="8" name="TextBox 7"/>
-          <p:cNvSpPr txBox="1"/>
-          <p:nvPr/>
-        </p:nvSpPr>
-        <p:spPr>
-          <a:xfrm>
-            <a:off x="1188720" y="3767328"/>
-            <a:ext cx="274320" cy="274320"/>
+            <a:ext cx="4572000" cy="320040"/>
           </a:xfrm>
           <a:prstGeom prst="rect">
             <a:avLst/>
@@ -8452,73 +8406,28 @@
               <a:spcAft>
                 <a:spcPts val="0"/>
               </a:spcAft>
-              <a:defRPr sz="1400" b="0">
-                <a:solidFill>
-                  <a:srgbClr val="4A7C59"/>
+              <a:defRPr sz="1300" b="0">
+                <a:solidFill>
+                  <a:srgbClr val="6B6860"/>
                 </a:solidFill>
                 <a:latin typeface="Calibri"/>
               </a:defRPr>
             </a:pPr>
             <a:r>
-              <a:t>•</a:t>
-            </a:r>
-          </a:p>
-        </p:txBody>
-      </p:sp>
-      <p:sp>
-        <p:nvSpPr>
-          <p:cNvPr id="9" name="TextBox 8"/>
+              <a:t>Working app with local voice transcription + graph-native storage</a:t>
+            </a:r>
+          </a:p>
+        </p:txBody>
+      </p:sp>
+      <p:sp>
+        <p:nvSpPr>
+          <p:cNvPr id="8" name="TextBox 7"/>
           <p:cNvSpPr txBox="1"/>
           <p:nvPr/>
         </p:nvSpPr>
         <p:spPr>
           <a:xfrm>
-            <a:off x="1554480" y="3749040"/>
-            <a:ext cx="4572000" cy="365760"/>
-          </a:xfrm>
-          <a:prstGeom prst="rect">
-            <a:avLst/>
-          </a:prstGeom>
-          <a:noFill/>
-        </p:spPr>
-        <p:txBody>
-          <a:bodyPr wrap="square">
-            <a:spAutoFit/>
-          </a:bodyPr>
-          <a:lstStyle/>
-          <a:p>
-            <a:pPr algn="l">
-              <a:lnSpc>
-                <a:spcPct val="130000"/>
-              </a:lnSpc>
-              <a:spcBef>
-                <a:spcPts val="0"/>
-              </a:spcBef>
-              <a:spcAft>
-                <a:spcPts val="0"/>
-              </a:spcAft>
-              <a:defRPr sz="1500" b="0">
-                <a:solidFill>
-                  <a:srgbClr val="6B6860"/>
-                </a:solidFill>
-                <a:latin typeface="Calibri"/>
-              </a:defRPr>
-            </a:pPr>
-            <a:r>
-              <a:t>MCP server with Things, Tags, Tools architecture</a:t>
-            </a:r>
-          </a:p>
-        </p:txBody>
-      </p:sp>
-      <p:sp>
-        <p:nvSpPr>
-          <p:cNvPr id="10" name="TextBox 9"/>
-          <p:cNvSpPr txBox="1"/>
-          <p:nvPr/>
-        </p:nvSpPr>
-        <p:spPr>
-          <a:xfrm>
-            <a:off x="1188720" y="4224528"/>
+            <a:off x="1188720" y="3694176"/>
             <a:ext cx="274320" cy="274320"/>
           </a:xfrm>
           <a:prstGeom prst="rect">
@@ -8542,7 +8451,7 @@
               <a:spcAft>
                 <a:spcPts val="0"/>
               </a:spcAft>
-              <a:defRPr sz="1400" b="0">
+              <a:defRPr sz="1200" b="0">
                 <a:solidFill>
                   <a:srgbClr val="4A7C59"/>
                 </a:solidFill>
@@ -8557,59 +8466,14 @@
       </p:sp>
       <p:sp>
         <p:nvSpPr>
-          <p:cNvPr id="11" name="TextBox 10"/>
+          <p:cNvPr id="9" name="TextBox 8"/>
           <p:cNvSpPr txBox="1"/>
           <p:nvPr/>
         </p:nvSpPr>
         <p:spPr>
           <a:xfrm>
-            <a:off x="1554480" y="4206240"/>
-            <a:ext cx="4572000" cy="365760"/>
-          </a:xfrm>
-          <a:prstGeom prst="rect">
-            <a:avLst/>
-          </a:prstGeom>
-          <a:noFill/>
-        </p:spPr>
-        <p:txBody>
-          <a:bodyPr wrap="square">
-            <a:spAutoFit/>
-          </a:bodyPr>
-          <a:lstStyle/>
-          <a:p>
-            <a:pPr algn="l">
-              <a:lnSpc>
-                <a:spcPct val="130000"/>
-              </a:lnSpc>
-              <a:spcBef>
-                <a:spcPts val="0"/>
-              </a:spcBef>
-              <a:spcAft>
-                <a:spcPts val="0"/>
-              </a:spcAft>
-              <a:defRPr sz="1500" b="0">
-                <a:solidFill>
-                  <a:srgbClr val="6B6860"/>
-                </a:solidFill>
-                <a:latin typeface="Calibri"/>
-              </a:defRPr>
-            </a:pPr>
-            <a:r>
-              <a:t>Functional pendant prototype (on stage today)</a:t>
-            </a:r>
-          </a:p>
-        </p:txBody>
-      </p:sp>
-      <p:sp>
-        <p:nvSpPr>
-          <p:cNvPr id="12" name="TextBox 11"/>
-          <p:cNvSpPr txBox="1"/>
-          <p:nvPr/>
-        </p:nvSpPr>
-        <p:spPr>
-          <a:xfrm>
-            <a:off x="1188720" y="4681728"/>
-            <a:ext cx="274320" cy="274320"/>
+            <a:off x="1554480" y="3675888"/>
+            <a:ext cx="4572000" cy="320040"/>
           </a:xfrm>
           <a:prstGeom prst="rect">
             <a:avLst/>
@@ -8632,73 +8496,28 @@
               <a:spcAft>
                 <a:spcPts val="0"/>
               </a:spcAft>
-              <a:defRPr sz="1400" b="0">
-                <a:solidFill>
-                  <a:srgbClr val="4A7C59"/>
+              <a:defRPr sz="1300" b="0">
+                <a:solidFill>
+                  <a:srgbClr val="6B6860"/>
                 </a:solidFill>
                 <a:latin typeface="Calibri"/>
               </a:defRPr>
             </a:pPr>
             <a:r>
-              <a:t>•</a:t>
-            </a:r>
-          </a:p>
-        </p:txBody>
-      </p:sp>
-      <p:sp>
-        <p:nvSpPr>
-          <p:cNvPr id="13" name="TextBox 12"/>
+              <a:t>MCP server with Things, Tags, Tools architecture</a:t>
+            </a:r>
+          </a:p>
+        </p:txBody>
+      </p:sp>
+      <p:sp>
+        <p:nvSpPr>
+          <p:cNvPr id="10" name="TextBox 9"/>
           <p:cNvSpPr txBox="1"/>
           <p:nvPr/>
         </p:nvSpPr>
         <p:spPr>
           <a:xfrm>
-            <a:off x="1554480" y="4663440"/>
-            <a:ext cx="4572000" cy="365760"/>
-          </a:xfrm>
-          <a:prstGeom prst="rect">
-            <a:avLst/>
-          </a:prstGeom>
-          <a:noFill/>
-        </p:spPr>
-        <p:txBody>
-          <a:bodyPr wrap="square">
-            <a:spAutoFit/>
-          </a:bodyPr>
-          <a:lstStyle/>
-          <a:p>
-            <a:pPr algn="l">
-              <a:lnSpc>
-                <a:spcPct val="130000"/>
-              </a:lnSpc>
-              <a:spcBef>
-                <a:spcPts val="0"/>
-              </a:spcBef>
-              <a:spcAft>
-                <a:spcPts val="0"/>
-              </a:spcAft>
-              <a:defRPr sz="1500" b="0">
-                <a:solidFill>
-                  <a:srgbClr val="6B6860"/>
-                </a:solidFill>
-                <a:latin typeface="Calibri"/>
-              </a:defRPr>
-            </a:pPr>
-            <a:r>
-              <a:t>Daily beta launching this month · PBC incorporated in Colorado</a:t>
-            </a:r>
-          </a:p>
-        </p:txBody>
-      </p:sp>
-      <p:sp>
-        <p:nvSpPr>
-          <p:cNvPr id="14" name="TextBox 13"/>
-          <p:cNvSpPr txBox="1"/>
-          <p:nvPr/>
-        </p:nvSpPr>
-        <p:spPr>
-          <a:xfrm>
-            <a:off x="1188720" y="5138928"/>
+            <a:off x="1188720" y="4078224"/>
             <a:ext cx="274320" cy="274320"/>
           </a:xfrm>
           <a:prstGeom prst="rect">
@@ -8722,7 +8541,7 @@
               <a:spcAft>
                 <a:spcPts val="0"/>
               </a:spcAft>
-              <a:defRPr sz="1400" b="0">
+              <a:defRPr sz="1200" b="0">
                 <a:solidFill>
                   <a:srgbClr val="4A7C59"/>
                 </a:solidFill>
@@ -8737,14 +8556,14 @@
       </p:sp>
       <p:sp>
         <p:nvSpPr>
-          <p:cNvPr id="15" name="TextBox 14"/>
+          <p:cNvPr id="11" name="TextBox 10"/>
           <p:cNvSpPr txBox="1"/>
           <p:nvPr/>
         </p:nvSpPr>
         <p:spPr>
           <a:xfrm>
-            <a:off x="1554480" y="5120640"/>
-            <a:ext cx="4572000" cy="365760"/>
+            <a:off x="1554480" y="4059936"/>
+            <a:ext cx="4572000" cy="320040"/>
           </a:xfrm>
           <a:prstGeom prst="rect">
             <a:avLst/>
@@ -8759,7 +8578,7 @@
           <a:p>
             <a:pPr algn="l">
               <a:lnSpc>
-                <a:spcPct val="130000"/>
+                <a:spcPct val="120000"/>
               </a:lnSpc>
               <a:spcBef>
                 <a:spcPts val="0"/>
@@ -8767,7 +8586,187 @@
               <a:spcAft>
                 <a:spcPts val="0"/>
               </a:spcAft>
-              <a:defRPr sz="1500" b="0">
+              <a:defRPr sz="1300" b="0">
+                <a:solidFill>
+                  <a:srgbClr val="6B6860"/>
+                </a:solidFill>
+                <a:latin typeface="Calibri"/>
+              </a:defRPr>
+            </a:pPr>
+            <a:r>
+              <a:t>Functional pendant prototype (on stage today)</a:t>
+            </a:r>
+          </a:p>
+        </p:txBody>
+      </p:sp>
+      <p:sp>
+        <p:nvSpPr>
+          <p:cNvPr id="12" name="TextBox 11"/>
+          <p:cNvSpPr txBox="1"/>
+          <p:nvPr/>
+        </p:nvSpPr>
+        <p:spPr>
+          <a:xfrm>
+            <a:off x="1188720" y="4462272"/>
+            <a:ext cx="274320" cy="274320"/>
+          </a:xfrm>
+          <a:prstGeom prst="rect">
+            <a:avLst/>
+          </a:prstGeom>
+          <a:noFill/>
+        </p:spPr>
+        <p:txBody>
+          <a:bodyPr wrap="square">
+            <a:spAutoFit/>
+          </a:bodyPr>
+          <a:lstStyle/>
+          <a:p>
+            <a:pPr algn="l">
+              <a:lnSpc>
+                <a:spcPct val="120000"/>
+              </a:lnSpc>
+              <a:spcBef>
+                <a:spcPts val="0"/>
+              </a:spcBef>
+              <a:spcAft>
+                <a:spcPts val="0"/>
+              </a:spcAft>
+              <a:defRPr sz="1200" b="0">
+                <a:solidFill>
+                  <a:srgbClr val="4A7C59"/>
+                </a:solidFill>
+                <a:latin typeface="Calibri"/>
+              </a:defRPr>
+            </a:pPr>
+            <a:r>
+              <a:t>•</a:t>
+            </a:r>
+          </a:p>
+        </p:txBody>
+      </p:sp>
+      <p:sp>
+        <p:nvSpPr>
+          <p:cNvPr id="13" name="TextBox 12"/>
+          <p:cNvSpPr txBox="1"/>
+          <p:nvPr/>
+        </p:nvSpPr>
+        <p:spPr>
+          <a:xfrm>
+            <a:off x="1554480" y="4443984"/>
+            <a:ext cx="4572000" cy="320040"/>
+          </a:xfrm>
+          <a:prstGeom prst="rect">
+            <a:avLst/>
+          </a:prstGeom>
+          <a:noFill/>
+        </p:spPr>
+        <p:txBody>
+          <a:bodyPr wrap="square">
+            <a:spAutoFit/>
+          </a:bodyPr>
+          <a:lstStyle/>
+          <a:p>
+            <a:pPr algn="l">
+              <a:lnSpc>
+                <a:spcPct val="120000"/>
+              </a:lnSpc>
+              <a:spcBef>
+                <a:spcPts val="0"/>
+              </a:spcBef>
+              <a:spcAft>
+                <a:spcPts val="0"/>
+              </a:spcAft>
+              <a:defRPr sz="1300" b="0">
+                <a:solidFill>
+                  <a:srgbClr val="6B6860"/>
+                </a:solidFill>
+                <a:latin typeface="Calibri"/>
+              </a:defRPr>
+            </a:pPr>
+            <a:r>
+              <a:t>Daily beta launching this month · PBC incorporated in Colorado</a:t>
+            </a:r>
+          </a:p>
+        </p:txBody>
+      </p:sp>
+      <p:sp>
+        <p:nvSpPr>
+          <p:cNvPr id="14" name="TextBox 13"/>
+          <p:cNvSpPr txBox="1"/>
+          <p:nvPr/>
+        </p:nvSpPr>
+        <p:spPr>
+          <a:xfrm>
+            <a:off x="1188720" y="4846320"/>
+            <a:ext cx="274320" cy="274320"/>
+          </a:xfrm>
+          <a:prstGeom prst="rect">
+            <a:avLst/>
+          </a:prstGeom>
+          <a:noFill/>
+        </p:spPr>
+        <p:txBody>
+          <a:bodyPr wrap="square">
+            <a:spAutoFit/>
+          </a:bodyPr>
+          <a:lstStyle/>
+          <a:p>
+            <a:pPr algn="l">
+              <a:lnSpc>
+                <a:spcPct val="120000"/>
+              </a:lnSpc>
+              <a:spcBef>
+                <a:spcPts val="0"/>
+              </a:spcBef>
+              <a:spcAft>
+                <a:spcPts val="0"/>
+              </a:spcAft>
+              <a:defRPr sz="1200" b="0">
+                <a:solidFill>
+                  <a:srgbClr val="4A7C59"/>
+                </a:solidFill>
+                <a:latin typeface="Calibri"/>
+              </a:defRPr>
+            </a:pPr>
+            <a:r>
+              <a:t>•</a:t>
+            </a:r>
+          </a:p>
+        </p:txBody>
+      </p:sp>
+      <p:sp>
+        <p:nvSpPr>
+          <p:cNvPr id="15" name="TextBox 14"/>
+          <p:cNvSpPr txBox="1"/>
+          <p:nvPr/>
+        </p:nvSpPr>
+        <p:spPr>
+          <a:xfrm>
+            <a:off x="1554480" y="4828032"/>
+            <a:ext cx="4572000" cy="320040"/>
+          </a:xfrm>
+          <a:prstGeom prst="rect">
+            <a:avLst/>
+          </a:prstGeom>
+          <a:noFill/>
+        </p:spPr>
+        <p:txBody>
+          <a:bodyPr wrap="square">
+            <a:spAutoFit/>
+          </a:bodyPr>
+          <a:lstStyle/>
+          <a:p>
+            <a:pPr algn="l">
+              <a:lnSpc>
+                <a:spcPct val="120000"/>
+              </a:lnSpc>
+              <a:spcBef>
+                <a:spcPts val="0"/>
+              </a:spcBef>
+              <a:spcAft>
+                <a:spcPts val="0"/>
+              </a:spcAft>
+              <a:defRPr sz="1300" b="0">
                 <a:solidFill>
                   <a:srgbClr val="6B6860"/>
                 </a:solidFill>

</xml_diff>